<commit_message>
Judges' testing guide with screenshots, how-to-test slide
- JUDGES.md: 2-minute tour, design-your-own run and client collaboration, step by step
  with 26 annotated screenshots of the live app (docs/judges/); accounts, controls,
  what to look for, troubleshooting; demo video link
- README links the guide at the top
- Deck: new slide 14 "How to test the prototype" (QR, steps, ready-made brief, guide link),
  16 pages, video link filled

Co-Authored-By: Claude Opus 5.5 <noreply@anthropic.com>
</commit_message>
<xml_diff>
--- a/submission/Naqsha_AI_Builder_Cup_Submission.pptx
+++ b/submission/Naqsha_AI_Builder_Cup_Submission.pptx
@@ -21,6 +21,7 @@
     <p:sldId id="267" r:id="rId17"/>
     <p:sldId id="268" r:id="rId18"/>
     <p:sldId id="269" r:id="rId19"/>
+    <p:sldId id="272" r:id="rId28"/>
     <p:sldId id="270" r:id="rId20"/>
     <p:sldId id="271" r:id="rId21"/>
   </p:sldIdLst>
@@ -15285,6 +15286,2906 @@
 </p:sld>
 </file>
 
+<file path=ppt/slides/slide17.xml><?xml version="1.0" encoding="utf-8"?>
+<p:sld xmlns:a="http://schemas.openxmlformats.org/drawingml/2006/main" xmlns:r="http://schemas.openxmlformats.org/officeDocument/2006/relationships" xmlns:mc="http://schemas.openxmlformats.org/markup-compatibility/2006" xmlns:mv="urn:schemas-microsoft-com:mac:vml" xmlns:p="http://schemas.openxmlformats.org/presentationml/2006/main" xmlns:c="http://schemas.openxmlformats.org/drawingml/2006/chart" xmlns:dgm="http://schemas.openxmlformats.org/drawingml/2006/diagram" xmlns:o="urn:schemas-microsoft-com:office:office" xmlns:v="urn:schemas-microsoft-com:vml" xmlns:pvml="urn:schemas-microsoft-com:office:powerpoint" xmlns:com="http://schemas.openxmlformats.org/drawingml/2006/compatibility" xmlns:p14="http://schemas.microsoft.com/office/powerpoint/2010/main" xmlns:p15="http://schemas.microsoft.com/office/powerpoint/2012/main" xmlns:ahyp="http://schemas.microsoft.com/office/drawing/2018/hyperlinkcolor">
+  <p:cSld>
+    <p:spTree>
+      <p:nvGrpSpPr>
+        <p:cNvPr id="163" name="Shape 163"/>
+        <p:cNvGrpSpPr/>
+        <p:nvPr/>
+      </p:nvGrpSpPr>
+      <p:grpSpPr>
+        <a:xfrm>
+          <a:off x="0" y="0"/>
+          <a:ext cx="0" cy="0"/>
+          <a:chOff x="0" y="0"/>
+          <a:chExt cx="0" cy="0"/>
+        </a:xfrm>
+      </p:grpSpPr>
+      <p:pic>
+        <p:nvPicPr>
+          <p:cNvPr id="164" name="Google Shape;164;p27" title="Frame 144.png"/>
+          <p:cNvPicPr preferRelativeResize="0"/>
+          <p:nvPr/>
+        </p:nvPicPr>
+        <p:blipFill rotWithShape="1">
+          <a:blip r:embed="rId3">
+            <a:alphaModFix/>
+          </a:blip>
+          <a:srcRect b="98001" l="0" r="0" t="0"/>
+          <a:stretch/>
+        </p:blipFill>
+        <p:spPr>
+          <a:xfrm>
+            <a:off x="0" y="5093562"/>
+            <a:ext cx="9144000" cy="54275"/>
+          </a:xfrm>
+          <a:prstGeom prst="rect">
+            <a:avLst/>
+          </a:prstGeom>
+          <a:noFill/>
+          <a:ln>
+            <a:noFill/>
+          </a:ln>
+        </p:spPr>
+      </p:pic>
+      <p:pic>
+        <p:nvPicPr>
+          <p:cNvPr id="165" name="Google Shape;165;p27" title="Group 427319979.png"/>
+          <p:cNvPicPr preferRelativeResize="0"/>
+          <p:nvPr/>
+        </p:nvPicPr>
+        <p:blipFill>
+          <a:blip r:embed="rId4">
+            <a:alphaModFix/>
+          </a:blip>
+          <a:stretch>
+            <a:fillRect/>
+          </a:stretch>
+        </p:blipFill>
+        <p:spPr>
+          <a:xfrm>
+            <a:off x="0" y="1"/>
+            <a:ext cx="9144000" cy="507359"/>
+          </a:xfrm>
+          <a:prstGeom prst="rect">
+            <a:avLst/>
+          </a:prstGeom>
+          <a:noFill/>
+          <a:ln>
+            <a:noFill/>
+          </a:ln>
+        </p:spPr>
+      </p:pic>
+      <p:sp>
+        <p:nvSpPr>
+          <p:cNvPr id="166" name="Google Shape;166;p27"/>
+          <p:cNvSpPr/>
+          <p:nvPr/>
+        </p:nvSpPr>
+        <p:spPr>
+          <a:xfrm>
+            <a:off x="-29250" y="5071875"/>
+            <a:ext cx="9173400" cy="97800"/>
+          </a:xfrm>
+          <a:prstGeom prst="rect">
+            <a:avLst/>
+          </a:prstGeom>
+          <a:solidFill>
+            <a:schemeClr val="dk1"/>
+          </a:solidFill>
+          <a:ln>
+            <a:noFill/>
+          </a:ln>
+        </p:spPr>
+        <p:txBody>
+          <a:bodyPr anchorCtr="0" anchor="ctr" bIns="91425" lIns="91425" spcFirstLastPara="1" rIns="91425" wrap="square" tIns="91425">
+            <a:noAutofit/>
+          </a:bodyPr>
+          <a:lstStyle/>
+          <a:p>
+            <a:pPr indent="0" lvl="0" marL="0" rtl="0" algn="ctr">
+              <a:spcBef>
+                <a:spcPts val="0"/>
+              </a:spcBef>
+              <a:spcAft>
+                <a:spcPts val="0"/>
+              </a:spcAft>
+              <a:buNone/>
+            </a:pPr>
+            <a:r>
+              <a:t/>
+            </a:r>
+            <a:endParaRPr/>
+          </a:p>
+        </p:txBody>
+      </p:sp>
+      <p:sp>
+        <p:nvSpPr>
+          <p:cNvPr id="167" name="Heading 167"/>
+          <p:cNvSpPr txBox="1"/>
+          <p:nvPr/>
+        </p:nvSpPr>
+        <p:spPr>
+          <a:xfrm>
+            <a:off x="265350" y="663825"/>
+            <a:ext cx="8943000" cy="561900"/>
+          </a:xfrm>
+          <a:prstGeom prst="rect">
+            <a:avLst/>
+          </a:prstGeom>
+          <a:noFill/>
+          <a:ln>
+            <a:noFill/>
+          </a:ln>
+        </p:spPr>
+        <p:txBody>
+          <a:bodyPr anchorCtr="0" anchor="t" bIns="91425" lIns="91425" spcFirstLastPara="1" rIns="91425" wrap="square" tIns="91425">
+            <a:noAutofit/>
+          </a:bodyPr>
+          <a:lstStyle/>
+          <a:p>
+            <a:pPr indent="0" lvl="0" marL="0" rtl="0" algn="l">
+              <a:spcBef>
+                <a:spcPts val="0"/>
+              </a:spcBef>
+              <a:spcAft>
+                <a:spcPts val="0"/>
+              </a:spcAft>
+              <a:buNone/>
+            </a:pPr>
+            <a:r>
+              <a:rPr lang="en-GB" sz="1600">
+                <a:latin typeface="Google Sans Flex Medium"/>
+                <a:ea typeface="Google Sans Flex Medium"/>
+                <a:cs typeface="Google Sans Flex Medium"/>
+                <a:sym typeface="Google Sans Flex Medium"/>
+              </a:rPr>
+              <a:t>How to test the prototype</a:t>
+            </a:r>
+            <a:endParaRPr sz="1600">
+              <a:latin typeface="Google Sans Flex Medium"/>
+              <a:ea typeface="Google Sans Flex Medium"/>
+              <a:cs typeface="Google Sans Flex Medium"/>
+              <a:sym typeface="Google Sans Flex Medium"/>
+            </a:endParaRPr>
+          </a:p>
+        </p:txBody>
+      </p:sp>
+      <p:sp>
+        <p:nvSpPr>
+          <p:cNvPr id="168" name="Head chip 168"/>
+          <p:cNvSpPr/>
+          <p:nvPr/>
+        </p:nvSpPr>
+        <p:spPr>
+          <a:xfrm>
+            <a:off x="7161149" y="763524"/>
+            <a:ext cx="1626235" cy="237744"/>
+          </a:xfrm>
+          <a:prstGeom prst="roundRect">
+            <a:avLst>
+              <a:gd name="adj" fmla="val 50000"/>
+            </a:avLst>
+          </a:prstGeom>
+          <a:solidFill>
+            <a:srgbClr val="EEEEF0"/>
+          </a:solidFill>
+          <a:ln>
+            <a:noFill/>
+          </a:ln>
+        </p:spPr>
+      </p:sp>
+      <p:sp>
+        <p:nvSpPr>
+          <p:cNvPr id="169" name="Head chip label 169"/>
+          <p:cNvSpPr txBox="1"/>
+          <p:nvPr/>
+        </p:nvSpPr>
+        <p:spPr>
+          <a:xfrm>
+            <a:off x="7252589" y="763524"/>
+            <a:ext cx="1470787" cy="237744"/>
+          </a:xfrm>
+          <a:prstGeom prst="rect">
+            <a:avLst/>
+          </a:prstGeom>
+          <a:noFill/>
+          <a:ln>
+            <a:noFill/>
+          </a:ln>
+        </p:spPr>
+        <p:txBody>
+          <a:bodyPr wrap="square" lIns="0" tIns="0" rIns="0" bIns="0" anchor="ctr" rtlCol="0">
+            <a:noAutofit/>
+          </a:bodyPr>
+          <a:lstStyle/>
+          <a:p>
+            <a:pPr marL="0" indent="0" algn="l" rtl="0">
+              <a:lnSpc>
+                <a:spcPct val="100000"/>
+              </a:lnSpc>
+              <a:spcBef>
+                <a:spcPts val="0"/>
+              </a:spcBef>
+              <a:spcAft>
+                <a:spcPts val="0"/>
+              </a:spcAft>
+              <a:buNone/>
+            </a:pPr>
+            <a:r>
+              <a:rPr lang="en-GB" sz="1000" b="0" i="0" dirty="0">
+                <a:solidFill>
+                  <a:srgbClr val="46464B"/>
+                </a:solidFill>
+                <a:latin typeface="Google Sans Flex Medium"/>
+                <a:ea typeface="Google Sans Flex Medium"/>
+                <a:cs typeface="Google Sans Flex Medium"/>
+                <a:sym typeface="Google Sans Flex Medium"/>
+              </a:rPr>
+              <a:t xml:space="preserve">Best in desktop Chrome</a:t>
+            </a:r>
+            <a:endParaRPr lang="en-GB" sz="1000" dirty="0">
+              <a:latin typeface="Google Sans Flex Medium"/>
+              <a:ea typeface="Google Sans Flex Medium"/>
+              <a:cs typeface="Google Sans Flex Medium"/>
+              <a:sym typeface="Google Sans Flex Medium"/>
+            </a:endParaRPr>
+          </a:p>
+        </p:txBody>
+      </p:sp>
+      <p:sp>
+        <p:nvSpPr>
+          <p:cNvPr id="170" name="Column card 170"/>
+          <p:cNvSpPr/>
+          <p:nvPr/>
+        </p:nvSpPr>
+        <p:spPr>
+          <a:xfrm>
+            <a:off x="356616" y="1097280"/>
+            <a:ext cx="1920240" cy="3419856"/>
+          </a:xfrm>
+          <a:prstGeom prst="roundRect">
+            <a:avLst>
+              <a:gd name="adj" fmla="val 4761"/>
+            </a:avLst>
+          </a:prstGeom>
+          <a:solidFill>
+            <a:srgbClr val="F5F5F7"/>
+          </a:solidFill>
+          <a:ln>
+            <a:noFill/>
+          </a:ln>
+        </p:spPr>
+      </p:sp>
+      <p:sp>
+        <p:nvSpPr>
+          <p:cNvPr id="171" name="Column icon circle 171"/>
+          <p:cNvSpPr/>
+          <p:nvPr/>
+        </p:nvSpPr>
+        <p:spPr>
+          <a:xfrm>
+            <a:off x="484632" y="1225296"/>
+            <a:ext cx="310896" cy="310896"/>
+          </a:xfrm>
+          <a:prstGeom prst="ellipse">
+            <a:avLst/>
+          </a:prstGeom>
+          <a:solidFill>
+            <a:srgbClr val="111113"/>
+          </a:solidFill>
+          <a:ln>
+            <a:noFill/>
+          </a:ln>
+        </p:spPr>
+      </p:sp>
+      <p:pic>
+        <p:nvPicPr>
+          <p:cNvPr id="172" name="Column icon 172" descr=""/>
+          <p:cNvPicPr>
+            <a:picLocks noChangeAspect="1"/>
+          </p:cNvPicPr>
+          <p:nvPr/>
+        </p:nvPicPr>
+        <p:blipFill>
+          <a:blip r:embed="rId5"/>
+          <a:stretch>
+            <a:fillRect/>
+          </a:stretch>
+        </p:blipFill>
+        <p:spPr>
+          <a:xfrm>
+            <a:off x="553029" y="1293693"/>
+            <a:ext cx="174102" cy="174102"/>
+          </a:xfrm>
+          <a:prstGeom prst="rect">
+            <a:avLst/>
+          </a:prstGeom>
+          <a:noFill/>
+          <a:ln>
+            <a:noFill/>
+          </a:ln>
+        </p:spPr>
+      </p:pic>
+      <p:sp>
+        <p:nvSpPr>
+          <p:cNvPr id="173" name="Column title 173"/>
+          <p:cNvSpPr txBox="1"/>
+          <p:nvPr/>
+        </p:nvSpPr>
+        <p:spPr>
+          <a:xfrm>
+            <a:off x="886968" y="1225296"/>
+            <a:ext cx="1335024" cy="310896"/>
+          </a:xfrm>
+          <a:prstGeom prst="rect">
+            <a:avLst/>
+          </a:prstGeom>
+          <a:noFill/>
+          <a:ln>
+            <a:noFill/>
+          </a:ln>
+        </p:spPr>
+        <p:txBody>
+          <a:bodyPr wrap="square" lIns="0" tIns="0" rIns="0" bIns="0" anchor="ctr" rtlCol="0">
+            <a:noAutofit/>
+          </a:bodyPr>
+          <a:lstStyle/>
+          <a:p>
+            <a:pPr marL="0" indent="0" algn="l" rtl="0">
+              <a:lnSpc>
+                <a:spcPct val="100000"/>
+              </a:lnSpc>
+              <a:spcBef>
+                <a:spcPts val="0"/>
+              </a:spcBef>
+              <a:spcAft>
+                <a:spcPts val="0"/>
+              </a:spcAft>
+              <a:buNone/>
+            </a:pPr>
+            <a:r>
+              <a:rPr lang="en-GB" sz="1400" b="0" i="0" dirty="0">
+                <a:solidFill>
+                  <a:srgbClr val="111113"/>
+                </a:solidFill>
+                <a:latin typeface="Google Sans Flex SemiBold"/>
+                <a:ea typeface="Google Sans Flex SemiBold"/>
+                <a:cs typeface="Google Sans Flex SemiBold"/>
+                <a:sym typeface="Google Sans Flex SemiBold"/>
+              </a:rPr>
+              <a:t xml:space="preserve">Open it</a:t>
+            </a:r>
+            <a:endParaRPr lang="en-GB" sz="1400" dirty="0">
+              <a:latin typeface="Google Sans Flex SemiBold"/>
+              <a:ea typeface="Google Sans Flex SemiBold"/>
+              <a:cs typeface="Google Sans Flex SemiBold"/>
+              <a:sym typeface="Google Sans Flex SemiBold"/>
+            </a:endParaRPr>
+          </a:p>
+        </p:txBody>
+      </p:sp>
+      <p:sp>
+        <p:nvSpPr>
+          <p:cNvPr id="174" name="QR frame 174"/>
+          <p:cNvSpPr/>
+          <p:nvPr/>
+        </p:nvSpPr>
+        <p:spPr>
+          <a:xfrm>
+            <a:off x="484632" y="1682496"/>
+            <a:ext cx="1335024" cy="1335024"/>
+          </a:xfrm>
+          <a:prstGeom prst="roundRect">
+            <a:avLst>
+              <a:gd name="adj" fmla="val 5479"/>
+            </a:avLst>
+          </a:prstGeom>
+          <a:solidFill>
+            <a:srgbClr val="FFFFFF"/>
+          </a:solidFill>
+          <a:ln w="9525">
+            <a:solidFill>
+              <a:srgbClr val="E4E4E7"/>
+            </a:solidFill>
+          </a:ln>
+        </p:spPr>
+      </p:sp>
+      <p:pic>
+        <p:nvPicPr>
+          <p:cNvPr id="175" name="QR code 175" descr="QR code for the live app">
+            <a:hlinkClick r:id="rId7"/>
+          </p:cNvPr>
+          <p:cNvPicPr>
+            <a:picLocks noChangeAspect="1"/>
+          </p:cNvPicPr>
+          <p:nvPr/>
+        </p:nvPicPr>
+        <p:blipFill>
+          <a:blip r:embed="rId6"/>
+          <a:stretch>
+            <a:fillRect/>
+          </a:stretch>
+        </p:blipFill>
+        <p:spPr>
+          <a:xfrm>
+            <a:off x="539496" y="1737360"/>
+            <a:ext cx="1225296" cy="1225296"/>
+          </a:xfrm>
+          <a:prstGeom prst="rect">
+            <a:avLst/>
+          </a:prstGeom>
+          <a:noFill/>
+          <a:ln>
+            <a:noFill/>
+          </a:ln>
+        </p:spPr>
+      </p:pic>
+      <p:sp>
+        <p:nvSpPr>
+          <p:cNvPr id="176" name="Live link 176"/>
+          <p:cNvSpPr txBox="1"/>
+          <p:nvPr/>
+        </p:nvSpPr>
+        <p:spPr>
+          <a:xfrm>
+            <a:off x="484632" y="3108960"/>
+            <a:ext cx="1664208" cy="352196"/>
+          </a:xfrm>
+          <a:prstGeom prst="rect">
+            <a:avLst/>
+          </a:prstGeom>
+          <a:noFill/>
+          <a:ln>
+            <a:noFill/>
+          </a:ln>
+        </p:spPr>
+        <p:txBody>
+          <a:bodyPr wrap="square" lIns="0" tIns="0" rIns="0" bIns="0" anchor="t" rtlCol="0">
+            <a:noAutofit/>
+          </a:bodyPr>
+          <a:lstStyle/>
+          <a:p>
+            <a:pPr marL="0" indent="0" algn="l" rtl="0">
+              <a:lnSpc>
+                <a:spcPct val="100000"/>
+              </a:lnSpc>
+              <a:spcBef>
+                <a:spcPts val="0"/>
+              </a:spcBef>
+              <a:spcAft>
+                <a:spcPts val="0"/>
+              </a:spcAft>
+              <a:buNone/>
+            </a:pPr>
+            <a:r>
+              <a:rPr lang="en-GB" sz="1050" b="0" i="0" dirty="0">
+                <a:solidFill>
+                  <a:srgbClr val="2747F5"/>
+                </a:solidFill>
+                <a:latin typeface="Google Sans Flex Medium"/>
+                <a:ea typeface="Google Sans Flex Medium"/>
+                <a:cs typeface="Google Sans Flex Medium"/>
+                <a:sym typeface="Google Sans Flex Medium"/>
+                <a:hlinkClick r:id="rId8"/>
+              </a:rPr>
+              <a:t xml:space="preserve">naqsha-242926648187.</a:t>
+            </a:r>
+            <a:endParaRPr lang="en-GB" sz="1050" dirty="0">
+              <a:latin typeface="Google Sans Flex Medium"/>
+              <a:ea typeface="Google Sans Flex Medium"/>
+              <a:cs typeface="Google Sans Flex Medium"/>
+              <a:sym typeface="Google Sans Flex Medium"/>
+            </a:endParaRPr>
+          </a:p>
+          <a:p>
+            <a:pPr marL="0" indent="0" algn="l" rtl="0">
+              <a:lnSpc>
+                <a:spcPct val="100000"/>
+              </a:lnSpc>
+              <a:spcBef>
+                <a:spcPts val="0"/>
+              </a:spcBef>
+              <a:spcAft>
+                <a:spcPts val="0"/>
+              </a:spcAft>
+              <a:buNone/>
+            </a:pPr>
+            <a:r>
+              <a:rPr lang="en-GB" sz="1050" b="0" i="0" dirty="0">
+                <a:solidFill>
+                  <a:srgbClr val="2747F5"/>
+                </a:solidFill>
+                <a:latin typeface="Google Sans Flex Medium"/>
+                <a:ea typeface="Google Sans Flex Medium"/>
+                <a:cs typeface="Google Sans Flex Medium"/>
+                <a:sym typeface="Google Sans Flex Medium"/>
+                <a:hlinkClick r:id="rId9"/>
+              </a:rPr>
+              <a:t xml:space="preserve">us-central1.run.app</a:t>
+            </a:r>
+            <a:endParaRPr lang="en-GB" sz="1050" dirty="0">
+              <a:latin typeface="Google Sans Flex Medium"/>
+              <a:ea typeface="Google Sans Flex Medium"/>
+              <a:cs typeface="Google Sans Flex Medium"/>
+              <a:sym typeface="Google Sans Flex Medium"/>
+            </a:endParaRPr>
+          </a:p>
+        </p:txBody>
+      </p:sp>
+      <p:pic>
+        <p:nvPicPr>
+          <p:cNvPr id="177" name="Check icon 177" descr=""/>
+          <p:cNvPicPr>
+            <a:picLocks noChangeAspect="1"/>
+          </p:cNvPicPr>
+          <p:nvPr/>
+        </p:nvPicPr>
+        <p:blipFill>
+          <a:blip r:embed="rId10"/>
+          <a:stretch>
+            <a:fillRect/>
+          </a:stretch>
+        </p:blipFill>
+        <p:spPr>
+          <a:xfrm>
+            <a:off x="466344" y="3589172"/>
+            <a:ext cx="182880" cy="182880"/>
+          </a:xfrm>
+          <a:prstGeom prst="rect">
+            <a:avLst/>
+          </a:prstGeom>
+          <a:noFill/>
+          <a:ln>
+            <a:noFill/>
+          </a:ln>
+        </p:spPr>
+      </p:pic>
+      <p:sp>
+        <p:nvSpPr>
+          <p:cNvPr id="178" name="No account 178"/>
+          <p:cNvSpPr txBox="1"/>
+          <p:nvPr/>
+        </p:nvSpPr>
+        <p:spPr>
+          <a:xfrm>
+            <a:off x="685800" y="3570884"/>
+            <a:ext cx="1463040" cy="219456"/>
+          </a:xfrm>
+          <a:prstGeom prst="rect">
+            <a:avLst/>
+          </a:prstGeom>
+          <a:noFill/>
+          <a:ln>
+            <a:noFill/>
+          </a:ln>
+        </p:spPr>
+        <p:txBody>
+          <a:bodyPr wrap="square" lIns="0" tIns="0" rIns="0" bIns="0" anchor="ctr" rtlCol="0">
+            <a:noAutofit/>
+          </a:bodyPr>
+          <a:lstStyle/>
+          <a:p>
+            <a:pPr marL="0" indent="0" algn="l" rtl="0">
+              <a:lnSpc>
+                <a:spcPct val="100000"/>
+              </a:lnSpc>
+              <a:spcBef>
+                <a:spcPts val="0"/>
+              </a:spcBef>
+              <a:spcAft>
+                <a:spcPts val="0"/>
+              </a:spcAft>
+              <a:buNone/>
+            </a:pPr>
+            <a:r>
+              <a:rPr lang="en-GB" sz="1200" b="0" i="0" dirty="0">
+                <a:solidFill>
+                  <a:srgbClr val="111113"/>
+                </a:solidFill>
+                <a:latin typeface="Google Sans Flex SemiBold"/>
+                <a:ea typeface="Google Sans Flex SemiBold"/>
+                <a:cs typeface="Google Sans Flex SemiBold"/>
+                <a:sym typeface="Google Sans Flex SemiBold"/>
+              </a:rPr>
+              <a:t xml:space="preserve">No account needed</a:t>
+            </a:r>
+            <a:endParaRPr lang="en-GB" sz="1200" dirty="0">
+              <a:latin typeface="Google Sans Flex SemiBold"/>
+              <a:ea typeface="Google Sans Flex SemiBold"/>
+              <a:cs typeface="Google Sans Flex SemiBold"/>
+              <a:sym typeface="Google Sans Flex SemiBold"/>
+            </a:endParaRPr>
+          </a:p>
+        </p:txBody>
+      </p:sp>
+      <p:sp>
+        <p:nvSpPr>
+          <p:cNvPr id="179" name="Guest note 179"/>
+          <p:cNvSpPr txBox="1"/>
+          <p:nvPr/>
+        </p:nvSpPr>
+        <p:spPr>
+          <a:xfrm>
+            <a:off x="484632" y="3826916"/>
+            <a:ext cx="1664208" cy="476220"/>
+          </a:xfrm>
+          <a:prstGeom prst="rect">
+            <a:avLst/>
+          </a:prstGeom>
+          <a:noFill/>
+          <a:ln>
+            <a:noFill/>
+          </a:ln>
+        </p:spPr>
+        <p:txBody>
+          <a:bodyPr wrap="square" lIns="0" tIns="0" rIns="0" bIns="0" anchor="t" rtlCol="0">
+            <a:noAutofit/>
+          </a:bodyPr>
+          <a:lstStyle/>
+          <a:p>
+            <a:pPr marL="0" indent="0" algn="l" rtl="0">
+              <a:lnSpc>
+                <a:spcPct val="96000"/>
+              </a:lnSpc>
+              <a:spcBef>
+                <a:spcPts val="0"/>
+              </a:spcBef>
+              <a:spcAft>
+                <a:spcPts val="0"/>
+              </a:spcAft>
+              <a:buNone/>
+            </a:pPr>
+            <a:r>
+              <a:rPr lang="en-GB" sz="1000" b="0" i="0" dirty="0">
+                <a:solidFill>
+                  <a:srgbClr val="46464B"/>
+                </a:solidFill>
+                <a:latin typeface="Google Sans Flex"/>
+                <a:ea typeface="Google Sans Flex"/>
+                <a:cs typeface="Google Sans Flex"/>
+                <a:sym typeface="Google Sans Flex"/>
+              </a:rPr>
+              <a:t xml:space="preserve">Samples and your own homes work as a guest, saved in this browser.</a:t>
+            </a:r>
+            <a:endParaRPr lang="en-GB" sz="1000" dirty="0">
+              <a:latin typeface="Google Sans Flex"/>
+              <a:ea typeface="Google Sans Flex"/>
+              <a:cs typeface="Google Sans Flex"/>
+              <a:sym typeface="Google Sans Flex"/>
+            </a:endParaRPr>
+          </a:p>
+        </p:txBody>
+      </p:sp>
+      <p:sp>
+        <p:nvSpPr>
+          <p:cNvPr id="180" name="Column card 180"/>
+          <p:cNvSpPr/>
+          <p:nvPr/>
+        </p:nvSpPr>
+        <p:spPr>
+          <a:xfrm>
+            <a:off x="2414016" y="1097280"/>
+            <a:ext cx="3017520" cy="3419856"/>
+          </a:xfrm>
+          <a:prstGeom prst="roundRect">
+            <a:avLst>
+              <a:gd name="adj" fmla="val 3030"/>
+            </a:avLst>
+          </a:prstGeom>
+          <a:solidFill>
+            <a:srgbClr val="F5F5F7"/>
+          </a:solidFill>
+          <a:ln>
+            <a:noFill/>
+          </a:ln>
+        </p:spPr>
+      </p:sp>
+      <p:sp>
+        <p:nvSpPr>
+          <p:cNvPr id="181" name="Column icon circle 181"/>
+          <p:cNvSpPr/>
+          <p:nvPr/>
+        </p:nvSpPr>
+        <p:spPr>
+          <a:xfrm>
+            <a:off x="2542032" y="1225296"/>
+            <a:ext cx="310896" cy="310896"/>
+          </a:xfrm>
+          <a:prstGeom prst="ellipse">
+            <a:avLst/>
+          </a:prstGeom>
+          <a:solidFill>
+            <a:srgbClr val="111113"/>
+          </a:solidFill>
+          <a:ln>
+            <a:noFill/>
+          </a:ln>
+        </p:spPr>
+      </p:sp>
+      <p:pic>
+        <p:nvPicPr>
+          <p:cNvPr id="182" name="Column icon 182" descr=""/>
+          <p:cNvPicPr>
+            <a:picLocks noChangeAspect="1"/>
+          </p:cNvPicPr>
+          <p:nvPr/>
+        </p:nvPicPr>
+        <p:blipFill>
+          <a:blip r:embed="rId11"/>
+          <a:stretch>
+            <a:fillRect/>
+          </a:stretch>
+        </p:blipFill>
+        <p:spPr>
+          <a:xfrm>
+            <a:off x="2610429" y="1293693"/>
+            <a:ext cx="174102" cy="174102"/>
+          </a:xfrm>
+          <a:prstGeom prst="rect">
+            <a:avLst/>
+          </a:prstGeom>
+          <a:noFill/>
+          <a:ln>
+            <a:noFill/>
+          </a:ln>
+        </p:spPr>
+      </p:pic>
+      <p:sp>
+        <p:nvSpPr>
+          <p:cNvPr id="183" name="Column title 183"/>
+          <p:cNvSpPr txBox="1"/>
+          <p:nvPr/>
+        </p:nvSpPr>
+        <p:spPr>
+          <a:xfrm>
+            <a:off x="2944368" y="1225296"/>
+            <a:ext cx="2432304" cy="310896"/>
+          </a:xfrm>
+          <a:prstGeom prst="rect">
+            <a:avLst/>
+          </a:prstGeom>
+          <a:noFill/>
+          <a:ln>
+            <a:noFill/>
+          </a:ln>
+        </p:spPr>
+        <p:txBody>
+          <a:bodyPr wrap="square" lIns="0" tIns="0" rIns="0" bIns="0" anchor="ctr" rtlCol="0">
+            <a:noAutofit/>
+          </a:bodyPr>
+          <a:lstStyle/>
+          <a:p>
+            <a:pPr marL="0" indent="0" algn="l" rtl="0">
+              <a:lnSpc>
+                <a:spcPct val="100000"/>
+              </a:lnSpc>
+              <a:spcBef>
+                <a:spcPts val="0"/>
+              </a:spcBef>
+              <a:spcAft>
+                <a:spcPts val="0"/>
+              </a:spcAft>
+              <a:buNone/>
+            </a:pPr>
+            <a:r>
+              <a:rPr lang="en-GB" sz="1400" b="0" i="0" dirty="0">
+                <a:solidFill>
+                  <a:srgbClr val="111113"/>
+                </a:solidFill>
+                <a:latin typeface="Google Sans Flex SemiBold"/>
+                <a:ea typeface="Google Sans Flex SemiBold"/>
+                <a:cs typeface="Google Sans Flex SemiBold"/>
+                <a:sym typeface="Google Sans Flex SemiBold"/>
+              </a:rPr>
+              <a:t xml:space="preserve">2-minute tour</a:t>
+            </a:r>
+            <a:r>
+              <a:rPr lang="en-GB" sz="1050" b="0" i="0" dirty="0">
+                <a:solidFill>
+                  <a:srgbClr val="6E6E73"/>
+                </a:solidFill>
+                <a:latin typeface="Google Sans Flex"/>
+                <a:ea typeface="Google Sans Flex"/>
+                <a:cs typeface="Google Sans Flex"/>
+                <a:sym typeface="Google Sans Flex"/>
+              </a:rPr>
+              <a:t xml:space="preserve">  no waiting</a:t>
+            </a:r>
+            <a:endParaRPr lang="en-GB" sz="1400" dirty="0">
+              <a:latin typeface="Google Sans Flex SemiBold"/>
+              <a:ea typeface="Google Sans Flex SemiBold"/>
+              <a:cs typeface="Google Sans Flex SemiBold"/>
+              <a:sym typeface="Google Sans Flex SemiBold"/>
+            </a:endParaRPr>
+          </a:p>
+        </p:txBody>
+      </p:sp>
+      <p:pic>
+        <p:nvPicPr>
+          <p:cNvPr id="184" name="Tour shot 184" descr="A sample home in Orbit (live screen)"/>
+          <p:cNvPicPr>
+            <a:picLocks noChangeAspect="1"/>
+          </p:cNvPicPr>
+          <p:nvPr/>
+        </p:nvPicPr>
+        <p:blipFill>
+          <a:blip r:embed="rId12"/>
+          <a:stretch>
+            <a:fillRect/>
+          </a:stretch>
+        </p:blipFill>
+        <p:spPr>
+          <a:xfrm>
+            <a:off x="2596896" y="1682496"/>
+            <a:ext cx="809793" cy="493776"/>
+          </a:xfrm>
+          <a:prstGeom prst="roundRect">
+            <a:avLst>
+              <a:gd name="adj" fmla="val 9259"/>
+            </a:avLst>
+          </a:prstGeom>
+          <a:noFill/>
+          <a:ln w="9525">
+            <a:solidFill>
+              <a:srgbClr val="E4E4E7"/>
+            </a:solidFill>
+          </a:ln>
+        </p:spPr>
+      </p:pic>
+      <p:sp>
+        <p:nvSpPr>
+          <p:cNvPr id="185" name="Step 185"/>
+          <p:cNvSpPr/>
+          <p:nvPr/>
+        </p:nvSpPr>
+        <p:spPr>
+          <a:xfrm>
+            <a:off x="2505456" y="1618488"/>
+            <a:ext cx="192024" cy="192024"/>
+          </a:xfrm>
+          <a:prstGeom prst="ellipse">
+            <a:avLst/>
+          </a:prstGeom>
+          <a:solidFill>
+            <a:srgbClr val="2747F5"/>
+          </a:solidFill>
+          <a:ln w="15875">
+            <a:solidFill>
+              <a:srgbClr val="FFFFFF"/>
+            </a:solidFill>
+          </a:ln>
+        </p:spPr>
+        <p:txBody>
+          <a:bodyPr wrap="square" lIns="0" tIns="0" rIns="0" bIns="0" anchor="ctr" rtlCol="0">
+            <a:noAutofit/>
+          </a:bodyPr>
+          <a:lstStyle/>
+          <a:p>
+            <a:pPr marL="0" indent="0" algn="ctr" rtl="0">
+              <a:lnSpc>
+                <a:spcPct val="100000"/>
+              </a:lnSpc>
+              <a:spcBef>
+                <a:spcPts val="0"/>
+              </a:spcBef>
+              <a:spcAft>
+                <a:spcPts val="0"/>
+              </a:spcAft>
+              <a:buNone/>
+            </a:pPr>
+            <a:r>
+              <a:rPr lang="en-GB" sz="850" b="0" i="0" dirty="0">
+                <a:solidFill>
+                  <a:srgbClr val="FFFFFF"/>
+                </a:solidFill>
+                <a:latin typeface="Google Sans Flex SemiBold"/>
+                <a:ea typeface="Google Sans Flex SemiBold"/>
+                <a:cs typeface="Google Sans Flex SemiBold"/>
+                <a:sym typeface="Google Sans Flex SemiBold"/>
+              </a:rPr>
+              <a:t xml:space="preserve">1</a:t>
+            </a:r>
+            <a:endParaRPr lang="en-GB" sz="850" dirty="0">
+              <a:latin typeface="Google Sans Flex SemiBold"/>
+              <a:ea typeface="Google Sans Flex SemiBold"/>
+              <a:cs typeface="Google Sans Flex SemiBold"/>
+              <a:sym typeface="Google Sans Flex SemiBold"/>
+            </a:endParaRPr>
+          </a:p>
+        </p:txBody>
+      </p:sp>
+      <p:sp>
+        <p:nvSpPr>
+          <p:cNvPr id="186" name="Tour step 186"/>
+          <p:cNvSpPr txBox="1"/>
+          <p:nvPr/>
+        </p:nvSpPr>
+        <p:spPr>
+          <a:xfrm>
+            <a:off x="3516417" y="1682496"/>
+            <a:ext cx="1823679" cy="493776"/>
+          </a:xfrm>
+          <a:prstGeom prst="rect">
+            <a:avLst/>
+          </a:prstGeom>
+          <a:noFill/>
+          <a:ln>
+            <a:noFill/>
+          </a:ln>
+        </p:spPr>
+        <p:txBody>
+          <a:bodyPr wrap="square" lIns="0" tIns="0" rIns="0" bIns="0" anchor="ctr" rtlCol="0">
+            <a:noAutofit/>
+          </a:bodyPr>
+          <a:lstStyle/>
+          <a:p>
+            <a:pPr marL="0" indent="0" algn="l" rtl="0">
+              <a:lnSpc>
+                <a:spcPct val="96000"/>
+              </a:lnSpc>
+              <a:spcBef>
+                <a:spcPts val="0"/>
+              </a:spcBef>
+              <a:spcAft>
+                <a:spcPts val="0"/>
+              </a:spcAft>
+              <a:buNone/>
+            </a:pPr>
+            <a:r>
+              <a:rPr lang="en-GB" sz="1000" b="0" i="0" dirty="0">
+                <a:solidFill>
+                  <a:srgbClr val="111113"/>
+                </a:solidFill>
+                <a:latin typeface="Google Sans Flex SemiBold"/>
+                <a:ea typeface="Google Sans Flex SemiBold"/>
+                <a:cs typeface="Google Sans Flex SemiBold"/>
+                <a:sym typeface="Google Sans Flex SemiBold"/>
+              </a:rPr>
+              <a:t xml:space="preserve">Explore a sample home</a:t>
+            </a:r>
+            <a:r>
+              <a:rPr lang="en-GB" sz="1000" b="0" i="0" dirty="0">
+                <a:solidFill>
+                  <a:srgbClr val="46464B"/>
+                </a:solidFill>
+                <a:latin typeface="Google Sans Flex"/>
+                <a:ea typeface="Google Sans Flex"/>
+                <a:cs typeface="Google Sans Flex"/>
+                <a:sym typeface="Google Sans Flex"/>
+              </a:rPr>
+              <a:t xml:space="preserve"> on the landing page. Your own copy opens in 3D in about 3 s.</a:t>
+            </a:r>
+            <a:endParaRPr lang="en-GB" sz="1000" dirty="0">
+              <a:latin typeface="Google Sans Flex SemiBold"/>
+              <a:ea typeface="Google Sans Flex SemiBold"/>
+              <a:cs typeface="Google Sans Flex SemiBold"/>
+              <a:sym typeface="Google Sans Flex SemiBold"/>
+            </a:endParaRPr>
+          </a:p>
+        </p:txBody>
+      </p:sp>
+      <p:pic>
+        <p:nvPicPr>
+          <p:cNvPr id="187" name="Tour shot 187" descr="View menu: Night (live screen)"/>
+          <p:cNvPicPr>
+            <a:picLocks noChangeAspect="1"/>
+          </p:cNvPicPr>
+          <p:nvPr/>
+        </p:nvPicPr>
+        <p:blipFill>
+          <a:blip r:embed="rId13"/>
+          <a:stretch>
+            <a:fillRect/>
+          </a:stretch>
+        </p:blipFill>
+        <p:spPr>
+          <a:xfrm>
+            <a:off x="2596896" y="2244852"/>
+            <a:ext cx="809793" cy="493776"/>
+          </a:xfrm>
+          <a:prstGeom prst="roundRect">
+            <a:avLst>
+              <a:gd name="adj" fmla="val 9259"/>
+            </a:avLst>
+          </a:prstGeom>
+          <a:noFill/>
+          <a:ln w="9525">
+            <a:solidFill>
+              <a:srgbClr val="E4E4E7"/>
+            </a:solidFill>
+          </a:ln>
+        </p:spPr>
+      </p:pic>
+      <p:sp>
+        <p:nvSpPr>
+          <p:cNvPr id="188" name="Step 188"/>
+          <p:cNvSpPr/>
+          <p:nvPr/>
+        </p:nvSpPr>
+        <p:spPr>
+          <a:xfrm>
+            <a:off x="2505456" y="2180844"/>
+            <a:ext cx="192024" cy="192024"/>
+          </a:xfrm>
+          <a:prstGeom prst="ellipse">
+            <a:avLst/>
+          </a:prstGeom>
+          <a:solidFill>
+            <a:srgbClr val="2747F5"/>
+          </a:solidFill>
+          <a:ln w="15875">
+            <a:solidFill>
+              <a:srgbClr val="FFFFFF"/>
+            </a:solidFill>
+          </a:ln>
+        </p:spPr>
+        <p:txBody>
+          <a:bodyPr wrap="square" lIns="0" tIns="0" rIns="0" bIns="0" anchor="ctr" rtlCol="0">
+            <a:noAutofit/>
+          </a:bodyPr>
+          <a:lstStyle/>
+          <a:p>
+            <a:pPr marL="0" indent="0" algn="ctr" rtl="0">
+              <a:lnSpc>
+                <a:spcPct val="100000"/>
+              </a:lnSpc>
+              <a:spcBef>
+                <a:spcPts val="0"/>
+              </a:spcBef>
+              <a:spcAft>
+                <a:spcPts val="0"/>
+              </a:spcAft>
+              <a:buNone/>
+            </a:pPr>
+            <a:r>
+              <a:rPr lang="en-GB" sz="850" b="0" i="0" dirty="0">
+                <a:solidFill>
+                  <a:srgbClr val="FFFFFF"/>
+                </a:solidFill>
+                <a:latin typeface="Google Sans Flex SemiBold"/>
+                <a:ea typeface="Google Sans Flex SemiBold"/>
+                <a:cs typeface="Google Sans Flex SemiBold"/>
+                <a:sym typeface="Google Sans Flex SemiBold"/>
+              </a:rPr>
+              <a:t xml:space="preserve">2</a:t>
+            </a:r>
+            <a:endParaRPr lang="en-GB" sz="850" dirty="0">
+              <a:latin typeface="Google Sans Flex SemiBold"/>
+              <a:ea typeface="Google Sans Flex SemiBold"/>
+              <a:cs typeface="Google Sans Flex SemiBold"/>
+              <a:sym typeface="Google Sans Flex SemiBold"/>
+            </a:endParaRPr>
+          </a:p>
+        </p:txBody>
+      </p:sp>
+      <p:sp>
+        <p:nvSpPr>
+          <p:cNvPr id="189" name="Tour step 189"/>
+          <p:cNvSpPr txBox="1"/>
+          <p:nvPr/>
+        </p:nvSpPr>
+        <p:spPr>
+          <a:xfrm>
+            <a:off x="3516417" y="2244852"/>
+            <a:ext cx="1823679" cy="493776"/>
+          </a:xfrm>
+          <a:prstGeom prst="rect">
+            <a:avLst/>
+          </a:prstGeom>
+          <a:noFill/>
+          <a:ln>
+            <a:noFill/>
+          </a:ln>
+        </p:spPr>
+        <p:txBody>
+          <a:bodyPr wrap="square" lIns="0" tIns="0" rIns="0" bIns="0" anchor="ctr" rtlCol="0">
+            <a:noAutofit/>
+          </a:bodyPr>
+          <a:lstStyle/>
+          <a:p>
+            <a:pPr marL="0" indent="0" algn="l" rtl="0">
+              <a:lnSpc>
+                <a:spcPct val="96000"/>
+              </a:lnSpc>
+              <a:spcBef>
+                <a:spcPts val="0"/>
+              </a:spcBef>
+              <a:spcAft>
+                <a:spcPts val="0"/>
+              </a:spcAft>
+              <a:buNone/>
+            </a:pPr>
+            <a:r>
+              <a:rPr lang="en-GB" sz="1000" b="0" i="0" dirty="0">
+                <a:solidFill>
+                  <a:srgbClr val="111113"/>
+                </a:solidFill>
+                <a:latin typeface="Google Sans Flex SemiBold"/>
+                <a:ea typeface="Google Sans Flex SemiBold"/>
+                <a:cs typeface="Google Sans Flex SemiBold"/>
+                <a:sym typeface="Google Sans Flex SemiBold"/>
+              </a:rPr>
+              <a:t xml:space="preserve">View</a:t>
+            </a:r>
+            <a:r>
+              <a:rPr lang="en-GB" sz="1000" b="0" i="0" dirty="0">
+                <a:solidFill>
+                  <a:srgbClr val="46464B"/>
+                </a:solidFill>
+                <a:latin typeface="Google Sans Flex"/>
+                <a:ea typeface="Google Sans Flex"/>
+                <a:cs typeface="Google Sans Flex"/>
+                <a:sym typeface="Google Sans Flex"/>
+              </a:rPr>
+              <a:t xml:space="preserve">: </a:t>
+            </a:r>
+            <a:r>
+              <a:rPr lang="en-GB" sz="1000" b="0" i="0" dirty="0">
+                <a:solidFill>
+                  <a:srgbClr val="111113"/>
+                </a:solidFill>
+                <a:latin typeface="Google Sans Flex SemiBold"/>
+                <a:ea typeface="Google Sans Flex SemiBold"/>
+                <a:cs typeface="Google Sans Flex SemiBold"/>
+                <a:sym typeface="Google Sans Flex SemiBold"/>
+              </a:rPr>
+              <a:t xml:space="preserve">Night</a:t>
+            </a:r>
+            <a:r>
+              <a:rPr lang="en-GB" sz="1000" b="0" i="0" dirty="0">
+                <a:solidFill>
+                  <a:srgbClr val="46464B"/>
+                </a:solidFill>
+                <a:latin typeface="Google Sans Flex"/>
+                <a:ea typeface="Google Sans Flex"/>
+                <a:cs typeface="Google Sans Flex"/>
+                <a:sym typeface="Google Sans Flex"/>
+              </a:rPr>
+              <a:t xml:space="preserve">, </a:t>
+            </a:r>
+            <a:r>
+              <a:rPr lang="en-GB" sz="1000" b="0" i="0" dirty="0">
+                <a:solidFill>
+                  <a:srgbClr val="111113"/>
+                </a:solidFill>
+                <a:latin typeface="Google Sans Flex SemiBold"/>
+                <a:ea typeface="Google Sans Flex SemiBold"/>
+                <a:cs typeface="Google Sans Flex SemiBold"/>
+                <a:sym typeface="Google Sans Flex SemiBold"/>
+              </a:rPr>
+              <a:t xml:space="preserve">Cut away</a:t>
+            </a:r>
+            <a:r>
+              <a:rPr lang="en-GB" sz="1000" b="0" i="0" dirty="0">
+                <a:solidFill>
+                  <a:srgbClr val="46464B"/>
+                </a:solidFill>
+                <a:latin typeface="Google Sans Flex"/>
+                <a:ea typeface="Google Sans Flex"/>
+                <a:cs typeface="Google Sans Flex"/>
+                <a:sym typeface="Google Sans Flex"/>
+              </a:rPr>
+              <a:t xml:space="preserve">, </a:t>
+            </a:r>
+            <a:r>
+              <a:rPr lang="en-GB" sz="1000" b="0" i="0" dirty="0">
+                <a:solidFill>
+                  <a:srgbClr val="111113"/>
+                </a:solidFill>
+                <a:latin typeface="Google Sans Flex SemiBold"/>
+                <a:ea typeface="Google Sans Flex SemiBold"/>
+                <a:cs typeface="Google Sans Flex SemiBold"/>
+                <a:sym typeface="Google Sans Flex SemiBold"/>
+              </a:rPr>
+              <a:t xml:space="preserve">Render this view</a:t>
+            </a:r>
+            <a:r>
+              <a:rPr lang="en-GB" sz="1000" b="0" i="0" dirty="0">
+                <a:solidFill>
+                  <a:srgbClr val="46464B"/>
+                </a:solidFill>
+                <a:latin typeface="Google Sans Flex"/>
+                <a:ea typeface="Google Sans Flex"/>
+                <a:cs typeface="Google Sans Flex"/>
+                <a:sym typeface="Google Sans Flex"/>
+              </a:rPr>
+              <a:t xml:space="preserve"> for a photoreal image in about 10 s.</a:t>
+            </a:r>
+            <a:endParaRPr lang="en-GB" sz="1000" dirty="0">
+              <a:latin typeface="Google Sans Flex SemiBold"/>
+              <a:ea typeface="Google Sans Flex SemiBold"/>
+              <a:cs typeface="Google Sans Flex SemiBold"/>
+              <a:sym typeface="Google Sans Flex SemiBold"/>
+            </a:endParaRPr>
+          </a:p>
+        </p:txBody>
+      </p:sp>
+      <p:pic>
+        <p:nvPicPr>
+          <p:cNvPr id="190" name="Tour shot 190" descr="Walk mode in a bedroom, with the minimap (live screen)"/>
+          <p:cNvPicPr>
+            <a:picLocks noChangeAspect="1"/>
+          </p:cNvPicPr>
+          <p:nvPr/>
+        </p:nvPicPr>
+        <p:blipFill>
+          <a:blip r:embed="rId14"/>
+          <a:stretch>
+            <a:fillRect/>
+          </a:stretch>
+        </p:blipFill>
+        <p:spPr>
+          <a:xfrm>
+            <a:off x="2596896" y="2807208"/>
+            <a:ext cx="809793" cy="493776"/>
+          </a:xfrm>
+          <a:prstGeom prst="roundRect">
+            <a:avLst>
+              <a:gd name="adj" fmla="val 9259"/>
+            </a:avLst>
+          </a:prstGeom>
+          <a:noFill/>
+          <a:ln w="9525">
+            <a:solidFill>
+              <a:srgbClr val="E4E4E7"/>
+            </a:solidFill>
+          </a:ln>
+        </p:spPr>
+      </p:pic>
+      <p:sp>
+        <p:nvSpPr>
+          <p:cNvPr id="191" name="Step 191"/>
+          <p:cNvSpPr/>
+          <p:nvPr/>
+        </p:nvSpPr>
+        <p:spPr>
+          <a:xfrm>
+            <a:off x="2505456" y="2743200"/>
+            <a:ext cx="192024" cy="192024"/>
+          </a:xfrm>
+          <a:prstGeom prst="ellipse">
+            <a:avLst/>
+          </a:prstGeom>
+          <a:solidFill>
+            <a:srgbClr val="2747F5"/>
+          </a:solidFill>
+          <a:ln w="15875">
+            <a:solidFill>
+              <a:srgbClr val="FFFFFF"/>
+            </a:solidFill>
+          </a:ln>
+        </p:spPr>
+        <p:txBody>
+          <a:bodyPr wrap="square" lIns="0" tIns="0" rIns="0" bIns="0" anchor="ctr" rtlCol="0">
+            <a:noAutofit/>
+          </a:bodyPr>
+          <a:lstStyle/>
+          <a:p>
+            <a:pPr marL="0" indent="0" algn="ctr" rtl="0">
+              <a:lnSpc>
+                <a:spcPct val="100000"/>
+              </a:lnSpc>
+              <a:spcBef>
+                <a:spcPts val="0"/>
+              </a:spcBef>
+              <a:spcAft>
+                <a:spcPts val="0"/>
+              </a:spcAft>
+              <a:buNone/>
+            </a:pPr>
+            <a:r>
+              <a:rPr lang="en-GB" sz="850" b="0" i="0" dirty="0">
+                <a:solidFill>
+                  <a:srgbClr val="FFFFFF"/>
+                </a:solidFill>
+                <a:latin typeface="Google Sans Flex SemiBold"/>
+                <a:ea typeface="Google Sans Flex SemiBold"/>
+                <a:cs typeface="Google Sans Flex SemiBold"/>
+                <a:sym typeface="Google Sans Flex SemiBold"/>
+              </a:rPr>
+              <a:t xml:space="preserve">3</a:t>
+            </a:r>
+            <a:endParaRPr lang="en-GB" sz="850" dirty="0">
+              <a:latin typeface="Google Sans Flex SemiBold"/>
+              <a:ea typeface="Google Sans Flex SemiBold"/>
+              <a:cs typeface="Google Sans Flex SemiBold"/>
+              <a:sym typeface="Google Sans Flex SemiBold"/>
+            </a:endParaRPr>
+          </a:p>
+        </p:txBody>
+      </p:sp>
+      <p:sp>
+        <p:nvSpPr>
+          <p:cNvPr id="192" name="Tour step 192"/>
+          <p:cNvSpPr txBox="1"/>
+          <p:nvPr/>
+        </p:nvSpPr>
+        <p:spPr>
+          <a:xfrm>
+            <a:off x="3516417" y="2807208"/>
+            <a:ext cx="1823679" cy="493776"/>
+          </a:xfrm>
+          <a:prstGeom prst="rect">
+            <a:avLst/>
+          </a:prstGeom>
+          <a:noFill/>
+          <a:ln>
+            <a:noFill/>
+          </a:ln>
+        </p:spPr>
+        <p:txBody>
+          <a:bodyPr wrap="square" lIns="0" tIns="0" rIns="0" bIns="0" anchor="ctr" rtlCol="0">
+            <a:noAutofit/>
+          </a:bodyPr>
+          <a:lstStyle/>
+          <a:p>
+            <a:pPr marL="0" indent="0" algn="l" rtl="0">
+              <a:lnSpc>
+                <a:spcPct val="96000"/>
+              </a:lnSpc>
+              <a:spcBef>
+                <a:spcPts val="0"/>
+              </a:spcBef>
+              <a:spcAft>
+                <a:spcPts val="0"/>
+              </a:spcAft>
+              <a:buNone/>
+            </a:pPr>
+            <a:r>
+              <a:rPr lang="en-GB" sz="1000" b="0" i="0" dirty="0">
+                <a:solidFill>
+                  <a:srgbClr val="111113"/>
+                </a:solidFill>
+                <a:latin typeface="Google Sans Flex SemiBold"/>
+                <a:ea typeface="Google Sans Flex SemiBold"/>
+                <a:cs typeface="Google Sans Flex SemiBold"/>
+                <a:sym typeface="Google Sans Flex SemiBold"/>
+              </a:rPr>
+              <a:t xml:space="preserve">Walk</a:t>
+            </a:r>
+            <a:r>
+              <a:rPr lang="en-GB" sz="1000" b="0" i="0" dirty="0">
+                <a:solidFill>
+                  <a:srgbClr val="46464B"/>
+                </a:solidFill>
+                <a:latin typeface="Google Sans Flex"/>
+                <a:ea typeface="Google Sans Flex"/>
+                <a:cs typeface="Google Sans Flex"/>
+                <a:sym typeface="Google Sans Flex"/>
+              </a:rPr>
+              <a:t xml:space="preserve"> (or press V). W A S D to move, </a:t>
+            </a:r>
+            <a:r>
+              <a:rPr lang="en-GB" sz="1000" b="0" i="0" dirty="0">
+                <a:solidFill>
+                  <a:srgbClr val="111113"/>
+                </a:solidFill>
+                <a:latin typeface="Google Sans Flex SemiBold"/>
+                <a:ea typeface="Google Sans Flex SemiBold"/>
+                <a:cs typeface="Google Sans Flex SemiBold"/>
+                <a:sym typeface="Google Sans Flex SemiBold"/>
+              </a:rPr>
+              <a:t xml:space="preserve">M</a:t>
+            </a:r>
+            <a:r>
+              <a:rPr lang="en-GB" sz="1000" b="0" i="0" dirty="0">
+                <a:solidFill>
+                  <a:srgbClr val="46464B"/>
+                </a:solidFill>
+                <a:latin typeface="Google Sans Flex"/>
+                <a:ea typeface="Google Sans Flex"/>
+                <a:cs typeface="Google Sans Flex"/>
+                <a:sym typeface="Google Sans Flex"/>
+              </a:rPr>
+              <a:t xml:space="preserve"> to go to any room.</a:t>
+            </a:r>
+            <a:endParaRPr lang="en-GB" sz="1000" dirty="0">
+              <a:latin typeface="Google Sans Flex SemiBold"/>
+              <a:ea typeface="Google Sans Flex SemiBold"/>
+              <a:cs typeface="Google Sans Flex SemiBold"/>
+              <a:sym typeface="Google Sans Flex SemiBold"/>
+            </a:endParaRPr>
+          </a:p>
+        </p:txBody>
+      </p:sp>
+      <p:pic>
+        <p:nvPicPr>
+          <p:cNvPr id="193" name="Tour shot 193" descr="A comment card with Pin it (live screen)"/>
+          <p:cNvPicPr>
+            <a:picLocks noChangeAspect="1"/>
+          </p:cNvPicPr>
+          <p:nvPr/>
+        </p:nvPicPr>
+        <p:blipFill>
+          <a:blip r:embed="rId15"/>
+          <a:stretch>
+            <a:fillRect/>
+          </a:stretch>
+        </p:blipFill>
+        <p:spPr>
+          <a:xfrm>
+            <a:off x="2596896" y="3369564"/>
+            <a:ext cx="809793" cy="493776"/>
+          </a:xfrm>
+          <a:prstGeom prst="roundRect">
+            <a:avLst>
+              <a:gd name="adj" fmla="val 9259"/>
+            </a:avLst>
+          </a:prstGeom>
+          <a:noFill/>
+          <a:ln w="9525">
+            <a:solidFill>
+              <a:srgbClr val="E4E4E7"/>
+            </a:solidFill>
+          </a:ln>
+        </p:spPr>
+      </p:pic>
+      <p:sp>
+        <p:nvSpPr>
+          <p:cNvPr id="194" name="Step 194"/>
+          <p:cNvSpPr/>
+          <p:nvPr/>
+        </p:nvSpPr>
+        <p:spPr>
+          <a:xfrm>
+            <a:off x="2505456" y="3305556"/>
+            <a:ext cx="192024" cy="192024"/>
+          </a:xfrm>
+          <a:prstGeom prst="ellipse">
+            <a:avLst/>
+          </a:prstGeom>
+          <a:solidFill>
+            <a:srgbClr val="2747F5"/>
+          </a:solidFill>
+          <a:ln w="15875">
+            <a:solidFill>
+              <a:srgbClr val="FFFFFF"/>
+            </a:solidFill>
+          </a:ln>
+        </p:spPr>
+        <p:txBody>
+          <a:bodyPr wrap="square" lIns="0" tIns="0" rIns="0" bIns="0" anchor="ctr" rtlCol="0">
+            <a:noAutofit/>
+          </a:bodyPr>
+          <a:lstStyle/>
+          <a:p>
+            <a:pPr marL="0" indent="0" algn="ctr" rtl="0">
+              <a:lnSpc>
+                <a:spcPct val="100000"/>
+              </a:lnSpc>
+              <a:spcBef>
+                <a:spcPts val="0"/>
+              </a:spcBef>
+              <a:spcAft>
+                <a:spcPts val="0"/>
+              </a:spcAft>
+              <a:buNone/>
+            </a:pPr>
+            <a:r>
+              <a:rPr lang="en-GB" sz="850" b="0" i="0" dirty="0">
+                <a:solidFill>
+                  <a:srgbClr val="FFFFFF"/>
+                </a:solidFill>
+                <a:latin typeface="Google Sans Flex SemiBold"/>
+                <a:ea typeface="Google Sans Flex SemiBold"/>
+                <a:cs typeface="Google Sans Flex SemiBold"/>
+                <a:sym typeface="Google Sans Flex SemiBold"/>
+              </a:rPr>
+              <a:t xml:space="preserve">4</a:t>
+            </a:r>
+            <a:endParaRPr lang="en-GB" sz="850" dirty="0">
+              <a:latin typeface="Google Sans Flex SemiBold"/>
+              <a:ea typeface="Google Sans Flex SemiBold"/>
+              <a:cs typeface="Google Sans Flex SemiBold"/>
+              <a:sym typeface="Google Sans Flex SemiBold"/>
+            </a:endParaRPr>
+          </a:p>
+        </p:txBody>
+      </p:sp>
+      <p:sp>
+        <p:nvSpPr>
+          <p:cNvPr id="195" name="Tour step 195"/>
+          <p:cNvSpPr txBox="1"/>
+          <p:nvPr/>
+        </p:nvSpPr>
+        <p:spPr>
+          <a:xfrm>
+            <a:off x="3516417" y="3369564"/>
+            <a:ext cx="1823679" cy="493776"/>
+          </a:xfrm>
+          <a:prstGeom prst="rect">
+            <a:avLst/>
+          </a:prstGeom>
+          <a:noFill/>
+          <a:ln>
+            <a:noFill/>
+          </a:ln>
+        </p:spPr>
+        <p:txBody>
+          <a:bodyPr wrap="square" lIns="0" tIns="0" rIns="0" bIns="0" anchor="ctr" rtlCol="0">
+            <a:noAutofit/>
+          </a:bodyPr>
+          <a:lstStyle/>
+          <a:p>
+            <a:pPr marL="0" indent="0" algn="l" rtl="0">
+              <a:lnSpc>
+                <a:spcPct val="96000"/>
+              </a:lnSpc>
+              <a:spcBef>
+                <a:spcPts val="0"/>
+              </a:spcBef>
+              <a:spcAft>
+                <a:spcPts val="0"/>
+              </a:spcAft>
+              <a:buNone/>
+            </a:pPr>
+            <a:r>
+              <a:rPr lang="en-GB" sz="1000" b="0" i="0" dirty="0">
+                <a:solidFill>
+                  <a:srgbClr val="46464B"/>
+                </a:solidFill>
+                <a:latin typeface="Google Sans Flex"/>
+                <a:ea typeface="Google Sans Flex"/>
+                <a:cs typeface="Google Sans Flex"/>
+                <a:sym typeface="Google Sans Flex"/>
+              </a:rPr>
+              <a:t xml:space="preserve">Press </a:t>
+            </a:r>
+            <a:r>
+              <a:rPr lang="en-GB" sz="1000" b="0" i="0" dirty="0">
+                <a:solidFill>
+                  <a:srgbClr val="111113"/>
+                </a:solidFill>
+                <a:latin typeface="Google Sans Flex SemiBold"/>
+                <a:ea typeface="Google Sans Flex SemiBold"/>
+                <a:cs typeface="Google Sans Flex SemiBold"/>
+                <a:sym typeface="Google Sans Flex SemiBold"/>
+              </a:rPr>
+              <a:t xml:space="preserve">C</a:t>
+            </a:r>
+            <a:r>
+              <a:rPr lang="en-GB" sz="1000" b="0" i="0" dirty="0">
+                <a:solidFill>
+                  <a:srgbClr val="46464B"/>
+                </a:solidFill>
+                <a:latin typeface="Google Sans Flex"/>
+                <a:ea typeface="Google Sans Flex"/>
+                <a:cs typeface="Google Sans Flex"/>
+                <a:sym typeface="Google Sans Flex"/>
+              </a:rPr>
+              <a:t xml:space="preserve">, click the house, type a note and click </a:t>
+            </a:r>
+            <a:r>
+              <a:rPr lang="en-GB" sz="1000" b="0" i="0" dirty="0">
+                <a:solidFill>
+                  <a:srgbClr val="111113"/>
+                </a:solidFill>
+                <a:latin typeface="Google Sans Flex SemiBold"/>
+                <a:ea typeface="Google Sans Flex SemiBold"/>
+                <a:cs typeface="Google Sans Flex SemiBold"/>
+                <a:sym typeface="Google Sans Flex SemiBold"/>
+              </a:rPr>
+              <a:t xml:space="preserve">Pin it</a:t>
+            </a:r>
+            <a:r>
+              <a:rPr lang="en-GB" sz="1000" b="0" i="0" dirty="0">
+                <a:solidFill>
+                  <a:srgbClr val="46464B"/>
+                </a:solidFill>
+                <a:latin typeface="Google Sans Flex"/>
+                <a:ea typeface="Google Sans Flex"/>
+                <a:cs typeface="Google Sans Flex"/>
+                <a:sym typeface="Google Sans Flex"/>
+              </a:rPr>
+              <a:t xml:space="preserve">.</a:t>
+            </a:r>
+            <a:endParaRPr lang="en-GB" sz="1000" dirty="0">
+              <a:latin typeface="Google Sans Flex"/>
+              <a:ea typeface="Google Sans Flex"/>
+              <a:cs typeface="Google Sans Flex"/>
+              <a:sym typeface="Google Sans Flex"/>
+            </a:endParaRPr>
+          </a:p>
+        </p:txBody>
+      </p:sp>
+      <p:pic>
+        <p:nvPicPr>
+          <p:cNvPr id="196" name="Tour shot 196" descr="The Compliance panel: passes all 37 LDA checks and 10 livable rules (live screen)"/>
+          <p:cNvPicPr>
+            <a:picLocks noChangeAspect="1"/>
+          </p:cNvPicPr>
+          <p:nvPr/>
+        </p:nvPicPr>
+        <p:blipFill>
+          <a:blip r:embed="rId16"/>
+          <a:stretch>
+            <a:fillRect/>
+          </a:stretch>
+        </p:blipFill>
+        <p:spPr>
+          <a:xfrm>
+            <a:off x="2596896" y="3931920"/>
+            <a:ext cx="809793" cy="493776"/>
+          </a:xfrm>
+          <a:prstGeom prst="roundRect">
+            <a:avLst>
+              <a:gd name="adj" fmla="val 9259"/>
+            </a:avLst>
+          </a:prstGeom>
+          <a:noFill/>
+          <a:ln w="9525">
+            <a:solidFill>
+              <a:srgbClr val="E4E4E7"/>
+            </a:solidFill>
+          </a:ln>
+        </p:spPr>
+      </p:pic>
+      <p:sp>
+        <p:nvSpPr>
+          <p:cNvPr id="197" name="Step 197"/>
+          <p:cNvSpPr/>
+          <p:nvPr/>
+        </p:nvSpPr>
+        <p:spPr>
+          <a:xfrm>
+            <a:off x="2505456" y="3867912"/>
+            <a:ext cx="192024" cy="192024"/>
+          </a:xfrm>
+          <a:prstGeom prst="ellipse">
+            <a:avLst/>
+          </a:prstGeom>
+          <a:solidFill>
+            <a:srgbClr val="2747F5"/>
+          </a:solidFill>
+          <a:ln w="15875">
+            <a:solidFill>
+              <a:srgbClr val="FFFFFF"/>
+            </a:solidFill>
+          </a:ln>
+        </p:spPr>
+        <p:txBody>
+          <a:bodyPr wrap="square" lIns="0" tIns="0" rIns="0" bIns="0" anchor="ctr" rtlCol="0">
+            <a:noAutofit/>
+          </a:bodyPr>
+          <a:lstStyle/>
+          <a:p>
+            <a:pPr marL="0" indent="0" algn="ctr" rtl="0">
+              <a:lnSpc>
+                <a:spcPct val="100000"/>
+              </a:lnSpc>
+              <a:spcBef>
+                <a:spcPts val="0"/>
+              </a:spcBef>
+              <a:spcAft>
+                <a:spcPts val="0"/>
+              </a:spcAft>
+              <a:buNone/>
+            </a:pPr>
+            <a:r>
+              <a:rPr lang="en-GB" sz="850" b="0" i="0" dirty="0">
+                <a:solidFill>
+                  <a:srgbClr val="FFFFFF"/>
+                </a:solidFill>
+                <a:latin typeface="Google Sans Flex SemiBold"/>
+                <a:ea typeface="Google Sans Flex SemiBold"/>
+                <a:cs typeface="Google Sans Flex SemiBold"/>
+                <a:sym typeface="Google Sans Flex SemiBold"/>
+              </a:rPr>
+              <a:t xml:space="preserve">5</a:t>
+            </a:r>
+            <a:endParaRPr lang="en-GB" sz="850" dirty="0">
+              <a:latin typeface="Google Sans Flex SemiBold"/>
+              <a:ea typeface="Google Sans Flex SemiBold"/>
+              <a:cs typeface="Google Sans Flex SemiBold"/>
+              <a:sym typeface="Google Sans Flex SemiBold"/>
+            </a:endParaRPr>
+          </a:p>
+        </p:txBody>
+      </p:sp>
+      <p:sp>
+        <p:nvSpPr>
+          <p:cNvPr id="198" name="Tour step 198"/>
+          <p:cNvSpPr txBox="1"/>
+          <p:nvPr/>
+        </p:nvSpPr>
+        <p:spPr>
+          <a:xfrm>
+            <a:off x="3516417" y="3931920"/>
+            <a:ext cx="1823679" cy="493776"/>
+          </a:xfrm>
+          <a:prstGeom prst="rect">
+            <a:avLst/>
+          </a:prstGeom>
+          <a:noFill/>
+          <a:ln>
+            <a:noFill/>
+          </a:ln>
+        </p:spPr>
+        <p:txBody>
+          <a:bodyPr wrap="square" lIns="0" tIns="0" rIns="0" bIns="0" anchor="ctr" rtlCol="0">
+            <a:noAutofit/>
+          </a:bodyPr>
+          <a:lstStyle/>
+          <a:p>
+            <a:pPr marL="0" indent="0" algn="l" rtl="0">
+              <a:lnSpc>
+                <a:spcPct val="96000"/>
+              </a:lnSpc>
+              <a:spcBef>
+                <a:spcPts val="0"/>
+              </a:spcBef>
+              <a:spcAft>
+                <a:spcPts val="0"/>
+              </a:spcAft>
+              <a:buNone/>
+            </a:pPr>
+            <a:r>
+              <a:rPr lang="en-GB" sz="1000" b="0" i="0" dirty="0">
+                <a:solidFill>
+                  <a:srgbClr val="46464B"/>
+                </a:solidFill>
+                <a:latin typeface="Google Sans Flex"/>
+                <a:ea typeface="Google Sans Flex"/>
+                <a:cs typeface="Google Sans Flex"/>
+                <a:sym typeface="Google Sans Flex"/>
+              </a:rPr>
+              <a:t xml:space="preserve">Open </a:t>
+            </a:r>
+            <a:r>
+              <a:rPr lang="en-GB" sz="1000" b="0" i="0" dirty="0">
+                <a:solidFill>
+                  <a:srgbClr val="111113"/>
+                </a:solidFill>
+                <a:latin typeface="Google Sans Flex SemiBold"/>
+                <a:ea typeface="Google Sans Flex SemiBold"/>
+                <a:cs typeface="Google Sans Flex SemiBold"/>
+                <a:sym typeface="Google Sans Flex SemiBold"/>
+              </a:rPr>
+              <a:t xml:space="preserve">Plan</a:t>
+            </a:r>
+            <a:r>
+              <a:rPr lang="en-GB" sz="1000" b="0" i="0" dirty="0">
+                <a:solidFill>
+                  <a:srgbClr val="46464B"/>
+                </a:solidFill>
+                <a:latin typeface="Google Sans Flex"/>
+                <a:ea typeface="Google Sans Flex"/>
+                <a:cs typeface="Google Sans Flex"/>
+                <a:sym typeface="Google Sans Flex"/>
+              </a:rPr>
+              <a:t xml:space="preserve"> and click </a:t>
+            </a:r>
+            <a:r>
+              <a:rPr lang="en-GB" sz="1000" b="0" i="0" dirty="0">
+                <a:solidFill>
+                  <a:srgbClr val="111113"/>
+                </a:solidFill>
+                <a:latin typeface="Google Sans Flex SemiBold"/>
+                <a:ea typeface="Google Sans Flex SemiBold"/>
+                <a:cs typeface="Google Sans Flex SemiBold"/>
+                <a:sym typeface="Google Sans Flex SemiBold"/>
+              </a:rPr>
+              <a:t xml:space="preserve">37/37 LDA</a:t>
+            </a:r>
+            <a:r>
+              <a:rPr lang="en-GB" sz="1000" b="0" i="0" dirty="0">
+                <a:solidFill>
+                  <a:srgbClr val="46464B"/>
+                </a:solidFill>
+                <a:latin typeface="Google Sans Flex"/>
+                <a:ea typeface="Google Sans Flex"/>
+                <a:cs typeface="Google Sans Flex"/>
+                <a:sym typeface="Google Sans Flex"/>
+              </a:rPr>
+              <a:t xml:space="preserve"> to see every bylaw check.</a:t>
+            </a:r>
+            <a:endParaRPr lang="en-GB" sz="1000" dirty="0">
+              <a:latin typeface="Google Sans Flex"/>
+              <a:ea typeface="Google Sans Flex"/>
+              <a:cs typeface="Google Sans Flex"/>
+              <a:sym typeface="Google Sans Flex"/>
+            </a:endParaRPr>
+          </a:p>
+        </p:txBody>
+      </p:sp>
+      <p:sp>
+        <p:nvSpPr>
+          <p:cNvPr id="199" name="Column card 199"/>
+          <p:cNvSpPr/>
+          <p:nvPr/>
+        </p:nvSpPr>
+        <p:spPr>
+          <a:xfrm>
+            <a:off x="5568696" y="1097280"/>
+            <a:ext cx="3218688" cy="3419856"/>
+          </a:xfrm>
+          <a:prstGeom prst="roundRect">
+            <a:avLst>
+              <a:gd name="adj" fmla="val 2840"/>
+            </a:avLst>
+          </a:prstGeom>
+          <a:solidFill>
+            <a:srgbClr val="F5F5F7"/>
+          </a:solidFill>
+          <a:ln>
+            <a:noFill/>
+          </a:ln>
+        </p:spPr>
+      </p:sp>
+      <p:sp>
+        <p:nvSpPr>
+          <p:cNvPr id="200" name="Column icon circle 200"/>
+          <p:cNvSpPr/>
+          <p:nvPr/>
+        </p:nvSpPr>
+        <p:spPr>
+          <a:xfrm>
+            <a:off x="5696712" y="1225296"/>
+            <a:ext cx="310896" cy="310896"/>
+          </a:xfrm>
+          <a:prstGeom prst="ellipse">
+            <a:avLst/>
+          </a:prstGeom>
+          <a:solidFill>
+            <a:srgbClr val="111113"/>
+          </a:solidFill>
+          <a:ln>
+            <a:noFill/>
+          </a:ln>
+        </p:spPr>
+      </p:sp>
+      <p:pic>
+        <p:nvPicPr>
+          <p:cNvPr id="201" name="Column icon 201" descr=""/>
+          <p:cNvPicPr>
+            <a:picLocks noChangeAspect="1"/>
+          </p:cNvPicPr>
+          <p:nvPr/>
+        </p:nvPicPr>
+        <p:blipFill>
+          <a:blip r:embed="rId17"/>
+          <a:stretch>
+            <a:fillRect/>
+          </a:stretch>
+        </p:blipFill>
+        <p:spPr>
+          <a:xfrm>
+            <a:off x="5765109" y="1293693"/>
+            <a:ext cx="174102" cy="174102"/>
+          </a:xfrm>
+          <a:prstGeom prst="rect">
+            <a:avLst/>
+          </a:prstGeom>
+          <a:noFill/>
+          <a:ln>
+            <a:noFill/>
+          </a:ln>
+        </p:spPr>
+      </p:pic>
+      <p:sp>
+        <p:nvSpPr>
+          <p:cNvPr id="202" name="Column title 202"/>
+          <p:cNvSpPr txBox="1"/>
+          <p:nvPr/>
+        </p:nvSpPr>
+        <p:spPr>
+          <a:xfrm>
+            <a:off x="6099048" y="1225296"/>
+            <a:ext cx="2633472" cy="310896"/>
+          </a:xfrm>
+          <a:prstGeom prst="rect">
+            <a:avLst/>
+          </a:prstGeom>
+          <a:noFill/>
+          <a:ln>
+            <a:noFill/>
+          </a:ln>
+        </p:spPr>
+        <p:txBody>
+          <a:bodyPr wrap="square" lIns="0" tIns="0" rIns="0" bIns="0" anchor="ctr" rtlCol="0">
+            <a:noAutofit/>
+          </a:bodyPr>
+          <a:lstStyle/>
+          <a:p>
+            <a:pPr marL="0" indent="0" algn="l" rtl="0">
+              <a:lnSpc>
+                <a:spcPct val="100000"/>
+              </a:lnSpc>
+              <a:spcBef>
+                <a:spcPts val="0"/>
+              </a:spcBef>
+              <a:spcAft>
+                <a:spcPts val="0"/>
+              </a:spcAft>
+              <a:buNone/>
+            </a:pPr>
+            <a:r>
+              <a:rPr lang="en-GB" sz="1400" b="0" i="0" dirty="0">
+                <a:solidFill>
+                  <a:srgbClr val="111113"/>
+                </a:solidFill>
+                <a:latin typeface="Google Sans Flex SemiBold"/>
+                <a:ea typeface="Google Sans Flex SemiBold"/>
+                <a:cs typeface="Google Sans Flex SemiBold"/>
+                <a:sym typeface="Google Sans Flex SemiBold"/>
+              </a:rPr>
+              <a:t xml:space="preserve">Design your own</a:t>
+            </a:r>
+            <a:r>
+              <a:rPr lang="en-GB" sz="1050" b="0" i="0" dirty="0">
+                <a:solidFill>
+                  <a:srgbClr val="6E6E73"/>
+                </a:solidFill>
+                <a:latin typeface="Google Sans Flex"/>
+                <a:ea typeface="Google Sans Flex"/>
+                <a:cs typeface="Google Sans Flex"/>
+                <a:sym typeface="Google Sans Flex"/>
+              </a:rPr>
+              <a:t xml:space="preserve">  about 10 min</a:t>
+            </a:r>
+            <a:endParaRPr lang="en-GB" sz="1400" dirty="0">
+              <a:latin typeface="Google Sans Flex SemiBold"/>
+              <a:ea typeface="Google Sans Flex SemiBold"/>
+              <a:cs typeface="Google Sans Flex SemiBold"/>
+              <a:sym typeface="Google Sans Flex SemiBold"/>
+            </a:endParaRPr>
+          </a:p>
+        </p:txBody>
+      </p:sp>
+      <p:sp>
+        <p:nvSpPr>
+          <p:cNvPr id="203" name="Step 203"/>
+          <p:cNvSpPr/>
+          <p:nvPr/>
+        </p:nvSpPr>
+        <p:spPr>
+          <a:xfrm>
+            <a:off x="5696712" y="1687068"/>
+            <a:ext cx="182880" cy="182880"/>
+          </a:xfrm>
+          <a:prstGeom prst="ellipse">
+            <a:avLst/>
+          </a:prstGeom>
+          <a:solidFill>
+            <a:srgbClr val="2747F5"/>
+          </a:solidFill>
+          <a:ln>
+            <a:noFill/>
+          </a:ln>
+        </p:spPr>
+        <p:txBody>
+          <a:bodyPr wrap="square" lIns="0" tIns="0" rIns="0" bIns="0" anchor="ctr" rtlCol="0">
+            <a:noAutofit/>
+          </a:bodyPr>
+          <a:lstStyle/>
+          <a:p>
+            <a:pPr marL="0" indent="0" algn="ctr" rtl="0">
+              <a:lnSpc>
+                <a:spcPct val="100000"/>
+              </a:lnSpc>
+              <a:spcBef>
+                <a:spcPts val="0"/>
+              </a:spcBef>
+              <a:spcAft>
+                <a:spcPts val="0"/>
+              </a:spcAft>
+              <a:buNone/>
+            </a:pPr>
+            <a:r>
+              <a:rPr lang="en-GB" sz="850" b="0" i="0" dirty="0">
+                <a:solidFill>
+                  <a:srgbClr val="FFFFFF"/>
+                </a:solidFill>
+                <a:latin typeface="Google Sans Flex SemiBold"/>
+                <a:ea typeface="Google Sans Flex SemiBold"/>
+                <a:cs typeface="Google Sans Flex SemiBold"/>
+                <a:sym typeface="Google Sans Flex SemiBold"/>
+              </a:rPr>
+              <a:t xml:space="preserve">1</a:t>
+            </a:r>
+            <a:endParaRPr lang="en-GB" sz="850" dirty="0">
+              <a:latin typeface="Google Sans Flex SemiBold"/>
+              <a:ea typeface="Google Sans Flex SemiBold"/>
+              <a:cs typeface="Google Sans Flex SemiBold"/>
+              <a:sym typeface="Google Sans Flex SemiBold"/>
+            </a:endParaRPr>
+          </a:p>
+        </p:txBody>
+      </p:sp>
+      <p:sp>
+        <p:nvSpPr>
+          <p:cNvPr id="204" name="Design step 204"/>
+          <p:cNvSpPr txBox="1"/>
+          <p:nvPr/>
+        </p:nvSpPr>
+        <p:spPr>
+          <a:xfrm>
+            <a:off x="5952744" y="1673352"/>
+            <a:ext cx="2743200" cy="170932"/>
+          </a:xfrm>
+          <a:prstGeom prst="rect">
+            <a:avLst/>
+          </a:prstGeom>
+          <a:noFill/>
+          <a:ln>
+            <a:noFill/>
+          </a:ln>
+        </p:spPr>
+        <p:txBody>
+          <a:bodyPr wrap="square" lIns="0" tIns="0" rIns="0" bIns="0" anchor="t" rtlCol="0">
+            <a:noAutofit/>
+          </a:bodyPr>
+          <a:lstStyle/>
+          <a:p>
+            <a:pPr marL="0" indent="0" algn="l" rtl="0">
+              <a:lnSpc>
+                <a:spcPct val="96000"/>
+              </a:lnSpc>
+              <a:spcBef>
+                <a:spcPts val="0"/>
+              </a:spcBef>
+              <a:spcAft>
+                <a:spcPts val="0"/>
+              </a:spcAft>
+              <a:buNone/>
+            </a:pPr>
+            <a:r>
+              <a:rPr lang="en-GB" sz="1000" b="0" i="0" dirty="0">
+                <a:solidFill>
+                  <a:srgbClr val="46464B"/>
+                </a:solidFill>
+                <a:latin typeface="Google Sans Flex"/>
+                <a:ea typeface="Google Sans Flex"/>
+                <a:cs typeface="Google Sans Flex"/>
+                <a:sym typeface="Google Sans Flex"/>
+              </a:rPr>
+              <a:t xml:space="preserve">Click </a:t>
+            </a:r>
+            <a:r>
+              <a:rPr lang="en-GB" sz="1000" b="0" i="0" dirty="0">
+                <a:solidFill>
+                  <a:srgbClr val="111113"/>
+                </a:solidFill>
+                <a:latin typeface="Google Sans Flex SemiBold"/>
+                <a:ea typeface="Google Sans Flex SemiBold"/>
+                <a:cs typeface="Google Sans Flex SemiBold"/>
+                <a:sym typeface="Google Sans Flex SemiBold"/>
+              </a:rPr>
+              <a:t xml:space="preserve">Start your home</a:t>
+            </a:r>
+            <a:r>
+              <a:rPr lang="en-GB" sz="1000" b="0" i="0" dirty="0">
+                <a:solidFill>
+                  <a:srgbClr val="46464B"/>
+                </a:solidFill>
+                <a:latin typeface="Google Sans Flex"/>
+                <a:ea typeface="Google Sans Flex"/>
+                <a:cs typeface="Google Sans Flex"/>
+                <a:sym typeface="Google Sans Flex"/>
+              </a:rPr>
+              <a:t xml:space="preserve"> (or </a:t>
+            </a:r>
+            <a:r>
+              <a:rPr lang="en-GB" sz="1000" b="0" i="0" dirty="0">
+                <a:solidFill>
+                  <a:srgbClr val="111113"/>
+                </a:solidFill>
+                <a:latin typeface="Google Sans Flex SemiBold"/>
+                <a:ea typeface="Google Sans Flex SemiBold"/>
+                <a:cs typeface="Google Sans Flex SemiBold"/>
+                <a:sym typeface="Google Sans Flex SemiBold"/>
+              </a:rPr>
+              <a:t xml:space="preserve">Portal</a:t>
+            </a:r>
+            <a:r>
+              <a:rPr lang="en-GB" sz="1000" b="0" i="0" dirty="0">
+                <a:solidFill>
+                  <a:srgbClr val="46464B"/>
+                </a:solidFill>
+                <a:latin typeface="Google Sans Flex"/>
+                <a:ea typeface="Google Sans Flex"/>
+                <a:cs typeface="Google Sans Flex"/>
+                <a:sym typeface="Google Sans Flex"/>
+              </a:rPr>
+              <a:t xml:space="preserve">, top right).</a:t>
+            </a:r>
+            <a:endParaRPr lang="en-GB" sz="1000" dirty="0">
+              <a:latin typeface="Google Sans Flex"/>
+              <a:ea typeface="Google Sans Flex"/>
+              <a:cs typeface="Google Sans Flex"/>
+              <a:sym typeface="Google Sans Flex"/>
+            </a:endParaRPr>
+          </a:p>
+        </p:txBody>
+      </p:sp>
+      <p:sp>
+        <p:nvSpPr>
+          <p:cNvPr id="205" name="Step 205"/>
+          <p:cNvSpPr/>
+          <p:nvPr/>
+        </p:nvSpPr>
+        <p:spPr>
+          <a:xfrm>
+            <a:off x="5696712" y="1941722"/>
+            <a:ext cx="182880" cy="182880"/>
+          </a:xfrm>
+          <a:prstGeom prst="ellipse">
+            <a:avLst/>
+          </a:prstGeom>
+          <a:solidFill>
+            <a:srgbClr val="2747F5"/>
+          </a:solidFill>
+          <a:ln>
+            <a:noFill/>
+          </a:ln>
+        </p:spPr>
+        <p:txBody>
+          <a:bodyPr wrap="square" lIns="0" tIns="0" rIns="0" bIns="0" anchor="ctr" rtlCol="0">
+            <a:noAutofit/>
+          </a:bodyPr>
+          <a:lstStyle/>
+          <a:p>
+            <a:pPr marL="0" indent="0" algn="ctr" rtl="0">
+              <a:lnSpc>
+                <a:spcPct val="100000"/>
+              </a:lnSpc>
+              <a:spcBef>
+                <a:spcPts val="0"/>
+              </a:spcBef>
+              <a:spcAft>
+                <a:spcPts val="0"/>
+              </a:spcAft>
+              <a:buNone/>
+            </a:pPr>
+            <a:r>
+              <a:rPr lang="en-GB" sz="850" b="0" i="0" dirty="0">
+                <a:solidFill>
+                  <a:srgbClr val="FFFFFF"/>
+                </a:solidFill>
+                <a:latin typeface="Google Sans Flex SemiBold"/>
+                <a:ea typeface="Google Sans Flex SemiBold"/>
+                <a:cs typeface="Google Sans Flex SemiBold"/>
+                <a:sym typeface="Google Sans Flex SemiBold"/>
+              </a:rPr>
+              <a:t xml:space="preserve">2</a:t>
+            </a:r>
+            <a:endParaRPr lang="en-GB" sz="850" dirty="0">
+              <a:latin typeface="Google Sans Flex SemiBold"/>
+              <a:ea typeface="Google Sans Flex SemiBold"/>
+              <a:cs typeface="Google Sans Flex SemiBold"/>
+              <a:sym typeface="Google Sans Flex SemiBold"/>
+            </a:endParaRPr>
+          </a:p>
+        </p:txBody>
+      </p:sp>
+      <p:sp>
+        <p:nvSpPr>
+          <p:cNvPr id="206" name="Design step 206"/>
+          <p:cNvSpPr txBox="1"/>
+          <p:nvPr/>
+        </p:nvSpPr>
+        <p:spPr>
+          <a:xfrm>
+            <a:off x="5952744" y="1928006"/>
+            <a:ext cx="2743200" cy="170932"/>
+          </a:xfrm>
+          <a:prstGeom prst="rect">
+            <a:avLst/>
+          </a:prstGeom>
+          <a:noFill/>
+          <a:ln>
+            <a:noFill/>
+          </a:ln>
+        </p:spPr>
+        <p:txBody>
+          <a:bodyPr wrap="square" lIns="0" tIns="0" rIns="0" bIns="0" anchor="t" rtlCol="0">
+            <a:noAutofit/>
+          </a:bodyPr>
+          <a:lstStyle/>
+          <a:p>
+            <a:pPr marL="0" indent="0" algn="l" rtl="0">
+              <a:lnSpc>
+                <a:spcPct val="96000"/>
+              </a:lnSpc>
+              <a:spcBef>
+                <a:spcPts val="0"/>
+              </a:spcBef>
+              <a:spcAft>
+                <a:spcPts val="0"/>
+              </a:spcAft>
+              <a:buNone/>
+            </a:pPr>
+            <a:r>
+              <a:rPr lang="en-GB" sz="1000" b="0" i="0" dirty="0">
+                <a:solidFill>
+                  <a:srgbClr val="46464B"/>
+                </a:solidFill>
+                <a:latin typeface="Google Sans Flex"/>
+                <a:ea typeface="Google Sans Flex"/>
+                <a:cs typeface="Google Sans Flex"/>
+                <a:sym typeface="Google Sans Flex"/>
+              </a:rPr>
+              <a:t xml:space="preserve">Paste this brief and press Enter:</a:t>
+            </a:r>
+            <a:endParaRPr lang="en-GB" sz="1000" dirty="0">
+              <a:latin typeface="Google Sans Flex"/>
+              <a:ea typeface="Google Sans Flex"/>
+              <a:cs typeface="Google Sans Flex"/>
+              <a:sym typeface="Google Sans Flex"/>
+            </a:endParaRPr>
+          </a:p>
+        </p:txBody>
+      </p:sp>
+      <p:sp>
+        <p:nvSpPr>
+          <p:cNvPr id="207" name="Brief box 207"/>
+          <p:cNvSpPr/>
+          <p:nvPr/>
+        </p:nvSpPr>
+        <p:spPr>
+          <a:xfrm>
+            <a:off x="5696712" y="2144658"/>
+            <a:ext cx="2962656" cy="906500"/>
+          </a:xfrm>
+          <a:prstGeom prst="roundRect">
+            <a:avLst>
+              <a:gd name="adj" fmla="val 6052"/>
+            </a:avLst>
+          </a:prstGeom>
+          <a:solidFill>
+            <a:srgbClr val="FFFFFF"/>
+          </a:solidFill>
+          <a:ln w="9525">
+            <a:solidFill>
+              <a:srgbClr val="E4E4E7"/>
+            </a:solidFill>
+          </a:ln>
+        </p:spPr>
+        <p:txBody>
+          <a:bodyPr wrap="square" lIns="109728" tIns="64008" rIns="292608" bIns="64008" anchor="t" rtlCol="0">
+            <a:noAutofit/>
+          </a:bodyPr>
+          <a:lstStyle/>
+          <a:p>
+            <a:pPr marL="0" indent="0" algn="l" rtl="0">
+              <a:lnSpc>
+                <a:spcPct val="96000"/>
+              </a:lnSpc>
+              <a:spcBef>
+                <a:spcPts val="0"/>
+              </a:spcBef>
+              <a:spcAft>
+                <a:spcPts val="0"/>
+              </a:spcAft>
+              <a:buNone/>
+            </a:pPr>
+            <a:r>
+              <a:rPr lang="en-GB" sz="850" b="0" i="0" dirty="0">
+                <a:solidFill>
+                  <a:srgbClr val="111113"/>
+                </a:solidFill>
+                <a:latin typeface="Google Sans Flex"/>
+                <a:ea typeface="Google Sans Flex"/>
+                <a:cs typeface="Google Sans Flex"/>
+                <a:sym typeface="Google Sans Flex"/>
+              </a:rPr>
+              <a:t xml:space="preserve">10 marla plot in Johar Town, Lahore, facing north, mid-row. Two storeys, 4 bedrooms with attached baths, drawing room, TV lounge, open kitchen plus a dirty kitchen, car porch for 2 cars. Blue plastic water tank, roof ready for solar. Modern contemporary style.</a:t>
+            </a:r>
+            <a:endParaRPr lang="en-GB" sz="850" dirty="0">
+              <a:latin typeface="Google Sans Flex"/>
+              <a:ea typeface="Google Sans Flex"/>
+              <a:cs typeface="Google Sans Flex"/>
+              <a:sym typeface="Google Sans Flex"/>
+            </a:endParaRPr>
+          </a:p>
+        </p:txBody>
+      </p:sp>
+      <p:sp>
+        <p:nvSpPr>
+          <p:cNvPr id="208" name="Step 208"/>
+          <p:cNvSpPr/>
+          <p:nvPr/>
+        </p:nvSpPr>
+        <p:spPr>
+          <a:xfrm>
+            <a:off x="5696712" y="3157740"/>
+            <a:ext cx="182880" cy="182880"/>
+          </a:xfrm>
+          <a:prstGeom prst="ellipse">
+            <a:avLst/>
+          </a:prstGeom>
+          <a:solidFill>
+            <a:srgbClr val="2747F5"/>
+          </a:solidFill>
+          <a:ln>
+            <a:noFill/>
+          </a:ln>
+        </p:spPr>
+        <p:txBody>
+          <a:bodyPr wrap="square" lIns="0" tIns="0" rIns="0" bIns="0" anchor="ctr" rtlCol="0">
+            <a:noAutofit/>
+          </a:bodyPr>
+          <a:lstStyle/>
+          <a:p>
+            <a:pPr marL="0" indent="0" algn="ctr" rtl="0">
+              <a:lnSpc>
+                <a:spcPct val="100000"/>
+              </a:lnSpc>
+              <a:spcBef>
+                <a:spcPts val="0"/>
+              </a:spcBef>
+              <a:spcAft>
+                <a:spcPts val="0"/>
+              </a:spcAft>
+              <a:buNone/>
+            </a:pPr>
+            <a:r>
+              <a:rPr lang="en-GB" sz="850" b="0" i="0" dirty="0">
+                <a:solidFill>
+                  <a:srgbClr val="FFFFFF"/>
+                </a:solidFill>
+                <a:latin typeface="Google Sans Flex SemiBold"/>
+                <a:ea typeface="Google Sans Flex SemiBold"/>
+                <a:cs typeface="Google Sans Flex SemiBold"/>
+                <a:sym typeface="Google Sans Flex SemiBold"/>
+              </a:rPr>
+              <a:t xml:space="preserve">3</a:t>
+            </a:r>
+            <a:endParaRPr lang="en-GB" sz="850" dirty="0">
+              <a:latin typeface="Google Sans Flex SemiBold"/>
+              <a:ea typeface="Google Sans Flex SemiBold"/>
+              <a:cs typeface="Google Sans Flex SemiBold"/>
+              <a:sym typeface="Google Sans Flex SemiBold"/>
+            </a:endParaRPr>
+          </a:p>
+        </p:txBody>
+      </p:sp>
+      <p:sp>
+        <p:nvSpPr>
+          <p:cNvPr id="209" name="Design step 209"/>
+          <p:cNvSpPr txBox="1"/>
+          <p:nvPr/>
+        </p:nvSpPr>
+        <p:spPr>
+          <a:xfrm>
+            <a:off x="5952744" y="3144024"/>
+            <a:ext cx="2743200" cy="323576"/>
+          </a:xfrm>
+          <a:prstGeom prst="rect">
+            <a:avLst/>
+          </a:prstGeom>
+          <a:noFill/>
+          <a:ln>
+            <a:noFill/>
+          </a:ln>
+        </p:spPr>
+        <p:txBody>
+          <a:bodyPr wrap="square" lIns="0" tIns="0" rIns="0" bIns="0" anchor="t" rtlCol="0">
+            <a:noAutofit/>
+          </a:bodyPr>
+          <a:lstStyle/>
+          <a:p>
+            <a:pPr marL="0" indent="0" algn="l" rtl="0">
+              <a:lnSpc>
+                <a:spcPct val="96000"/>
+              </a:lnSpc>
+              <a:spcBef>
+                <a:spcPts val="0"/>
+              </a:spcBef>
+              <a:spcAft>
+                <a:spcPts val="0"/>
+              </a:spcAft>
+              <a:buNone/>
+            </a:pPr>
+            <a:r>
+              <a:rPr lang="en-GB" sz="1000" b="0" i="0" dirty="0">
+                <a:solidFill>
+                  <a:srgbClr val="46464B"/>
+                </a:solidFill>
+                <a:latin typeface="Google Sans Flex"/>
+                <a:ea typeface="Google Sans Flex"/>
+                <a:cs typeface="Google Sans Flex"/>
+                <a:sym typeface="Google Sans Flex"/>
+              </a:rPr>
+              <a:t xml:space="preserve">Click </a:t>
+            </a:r>
+            <a:r>
+              <a:rPr lang="en-GB" sz="1000" b="0" i="0" dirty="0">
+                <a:solidFill>
+                  <a:srgbClr val="111113"/>
+                </a:solidFill>
+                <a:latin typeface="Google Sans Flex SemiBold"/>
+                <a:ea typeface="Google Sans Flex SemiBold"/>
+                <a:cs typeface="Google Sans Flex SemiBold"/>
+                <a:sym typeface="Google Sans Flex SemiBold"/>
+              </a:rPr>
+              <a:t xml:space="preserve">Use these floors</a:t>
+            </a:r>
+            <a:r>
+              <a:rPr lang="en-GB" sz="1000" b="0" i="0" dirty="0">
+                <a:solidFill>
+                  <a:srgbClr val="46464B"/>
+                </a:solidFill>
+                <a:latin typeface="Google Sans Flex"/>
+                <a:ea typeface="Google Sans Flex"/>
+                <a:cs typeface="Google Sans Flex"/>
+                <a:sym typeface="Google Sans Flex"/>
+              </a:rPr>
+              <a:t xml:space="preserve">, then </a:t>
+            </a:r>
+            <a:r>
+              <a:rPr lang="en-GB" sz="1000" b="0" i="0" dirty="0">
+                <a:solidFill>
+                  <a:srgbClr val="111113"/>
+                </a:solidFill>
+                <a:latin typeface="Google Sans Flex SemiBold"/>
+                <a:ea typeface="Google Sans Flex SemiBold"/>
+                <a:cs typeface="Google Sans Flex SemiBold"/>
+                <a:sym typeface="Google Sans Flex SemiBold"/>
+              </a:rPr>
+              <a:t xml:space="preserve">Show me concepts</a:t>
+            </a:r>
+            <a:r>
+              <a:rPr lang="en-GB" sz="1000" b="0" i="0" dirty="0">
+                <a:solidFill>
+                  <a:srgbClr val="46464B"/>
+                </a:solidFill>
+                <a:latin typeface="Google Sans Flex"/>
+                <a:ea typeface="Google Sans Flex"/>
+                <a:cs typeface="Google Sans Flex"/>
+                <a:sym typeface="Google Sans Flex"/>
+              </a:rPr>
+              <a:t xml:space="preserve">: four looks in about 20 s.</a:t>
+            </a:r>
+            <a:endParaRPr lang="en-GB" sz="1000" dirty="0">
+              <a:latin typeface="Google Sans Flex"/>
+              <a:ea typeface="Google Sans Flex"/>
+              <a:cs typeface="Google Sans Flex"/>
+              <a:sym typeface="Google Sans Flex"/>
+            </a:endParaRPr>
+          </a:p>
+        </p:txBody>
+      </p:sp>
+      <p:sp>
+        <p:nvSpPr>
+          <p:cNvPr id="210" name="Step 210"/>
+          <p:cNvSpPr/>
+          <p:nvPr/>
+        </p:nvSpPr>
+        <p:spPr>
+          <a:xfrm>
+            <a:off x="5696712" y="3565038"/>
+            <a:ext cx="182880" cy="182880"/>
+          </a:xfrm>
+          <a:prstGeom prst="ellipse">
+            <a:avLst/>
+          </a:prstGeom>
+          <a:solidFill>
+            <a:srgbClr val="2747F5"/>
+          </a:solidFill>
+          <a:ln>
+            <a:noFill/>
+          </a:ln>
+        </p:spPr>
+        <p:txBody>
+          <a:bodyPr wrap="square" lIns="0" tIns="0" rIns="0" bIns="0" anchor="ctr" rtlCol="0">
+            <a:noAutofit/>
+          </a:bodyPr>
+          <a:lstStyle/>
+          <a:p>
+            <a:pPr marL="0" indent="0" algn="ctr" rtl="0">
+              <a:lnSpc>
+                <a:spcPct val="100000"/>
+              </a:lnSpc>
+              <a:spcBef>
+                <a:spcPts val="0"/>
+              </a:spcBef>
+              <a:spcAft>
+                <a:spcPts val="0"/>
+              </a:spcAft>
+              <a:buNone/>
+            </a:pPr>
+            <a:r>
+              <a:rPr lang="en-GB" sz="850" b="0" i="0" dirty="0">
+                <a:solidFill>
+                  <a:srgbClr val="FFFFFF"/>
+                </a:solidFill>
+                <a:latin typeface="Google Sans Flex SemiBold"/>
+                <a:ea typeface="Google Sans Flex SemiBold"/>
+                <a:cs typeface="Google Sans Flex SemiBold"/>
+                <a:sym typeface="Google Sans Flex SemiBold"/>
+              </a:rPr>
+              <a:t xml:space="preserve">4</a:t>
+            </a:r>
+            <a:endParaRPr lang="en-GB" sz="850" dirty="0">
+              <a:latin typeface="Google Sans Flex SemiBold"/>
+              <a:ea typeface="Google Sans Flex SemiBold"/>
+              <a:cs typeface="Google Sans Flex SemiBold"/>
+              <a:sym typeface="Google Sans Flex SemiBold"/>
+            </a:endParaRPr>
+          </a:p>
+        </p:txBody>
+      </p:sp>
+      <p:sp>
+        <p:nvSpPr>
+          <p:cNvPr id="211" name="Design step 211"/>
+          <p:cNvSpPr txBox="1"/>
+          <p:nvPr/>
+        </p:nvSpPr>
+        <p:spPr>
+          <a:xfrm>
+            <a:off x="5952744" y="3551322"/>
+            <a:ext cx="2743200" cy="476220"/>
+          </a:xfrm>
+          <a:prstGeom prst="rect">
+            <a:avLst/>
+          </a:prstGeom>
+          <a:noFill/>
+          <a:ln>
+            <a:noFill/>
+          </a:ln>
+        </p:spPr>
+        <p:txBody>
+          <a:bodyPr wrap="square" lIns="0" tIns="0" rIns="0" bIns="0" anchor="t" rtlCol="0">
+            <a:noAutofit/>
+          </a:bodyPr>
+          <a:lstStyle/>
+          <a:p>
+            <a:pPr marL="0" indent="0" algn="l" rtl="0">
+              <a:lnSpc>
+                <a:spcPct val="96000"/>
+              </a:lnSpc>
+              <a:spcBef>
+                <a:spcPts val="0"/>
+              </a:spcBef>
+              <a:spcAft>
+                <a:spcPts val="0"/>
+              </a:spcAft>
+              <a:buNone/>
+            </a:pPr>
+            <a:r>
+              <a:rPr lang="en-GB" sz="1000" b="0" i="0" dirty="0">
+                <a:solidFill>
+                  <a:srgbClr val="46464B"/>
+                </a:solidFill>
+                <a:latin typeface="Google Sans Flex"/>
+                <a:ea typeface="Google Sans Flex"/>
+                <a:cs typeface="Google Sans Flex"/>
+                <a:sym typeface="Google Sans Flex"/>
+              </a:rPr>
+              <a:t xml:space="preserve">Open one and click </a:t>
+            </a:r>
+            <a:r>
+              <a:rPr lang="en-GB" sz="1000" b="0" i="0" dirty="0">
+                <a:solidFill>
+                  <a:srgbClr val="111113"/>
+                </a:solidFill>
+                <a:latin typeface="Google Sans Flex SemiBold"/>
+                <a:ea typeface="Google Sans Flex SemiBold"/>
+                <a:cs typeface="Google Sans Flex SemiBold"/>
+                <a:sym typeface="Google Sans Flex SemiBold"/>
+              </a:rPr>
+              <a:t xml:space="preserve">Plan this one</a:t>
+            </a:r>
+            <a:r>
+              <a:rPr lang="en-GB" sz="1000" b="0" i="0" dirty="0">
+                <a:solidFill>
+                  <a:srgbClr val="46464B"/>
+                </a:solidFill>
+                <a:latin typeface="Google Sans Flex"/>
+                <a:ea typeface="Google Sans Flex"/>
+                <a:cs typeface="Google Sans Flex"/>
+                <a:sym typeface="Google Sans Flex"/>
+              </a:rPr>
+              <a:t xml:space="preserve">. Naqsha plans, checks the bylaws, fixes and builds it in 3D in about 5–6 min. You can close the tab.</a:t>
+            </a:r>
+            <a:endParaRPr lang="en-GB" sz="1000" dirty="0">
+              <a:latin typeface="Google Sans Flex"/>
+              <a:ea typeface="Google Sans Flex"/>
+              <a:cs typeface="Google Sans Flex"/>
+              <a:sym typeface="Google Sans Flex"/>
+            </a:endParaRPr>
+          </a:p>
+        </p:txBody>
+      </p:sp>
+      <p:sp>
+        <p:nvSpPr>
+          <p:cNvPr id="212" name="Step 212"/>
+          <p:cNvSpPr/>
+          <p:nvPr/>
+        </p:nvSpPr>
+        <p:spPr>
+          <a:xfrm>
+            <a:off x="5696712" y="4124980"/>
+            <a:ext cx="182880" cy="182880"/>
+          </a:xfrm>
+          <a:prstGeom prst="ellipse">
+            <a:avLst/>
+          </a:prstGeom>
+          <a:solidFill>
+            <a:srgbClr val="2747F5"/>
+          </a:solidFill>
+          <a:ln>
+            <a:noFill/>
+          </a:ln>
+        </p:spPr>
+        <p:txBody>
+          <a:bodyPr wrap="square" lIns="0" tIns="0" rIns="0" bIns="0" anchor="ctr" rtlCol="0">
+            <a:noAutofit/>
+          </a:bodyPr>
+          <a:lstStyle/>
+          <a:p>
+            <a:pPr marL="0" indent="0" algn="ctr" rtl="0">
+              <a:lnSpc>
+                <a:spcPct val="100000"/>
+              </a:lnSpc>
+              <a:spcBef>
+                <a:spcPts val="0"/>
+              </a:spcBef>
+              <a:spcAft>
+                <a:spcPts val="0"/>
+              </a:spcAft>
+              <a:buNone/>
+            </a:pPr>
+            <a:r>
+              <a:rPr lang="en-GB" sz="850" b="0" i="0" dirty="0">
+                <a:solidFill>
+                  <a:srgbClr val="FFFFFF"/>
+                </a:solidFill>
+                <a:latin typeface="Google Sans Flex SemiBold"/>
+                <a:ea typeface="Google Sans Flex SemiBold"/>
+                <a:cs typeface="Google Sans Flex SemiBold"/>
+                <a:sym typeface="Google Sans Flex SemiBold"/>
+              </a:rPr>
+              <a:t xml:space="preserve">5</a:t>
+            </a:r>
+            <a:endParaRPr lang="en-GB" sz="850" dirty="0">
+              <a:latin typeface="Google Sans Flex SemiBold"/>
+              <a:ea typeface="Google Sans Flex SemiBold"/>
+              <a:cs typeface="Google Sans Flex SemiBold"/>
+              <a:sym typeface="Google Sans Flex SemiBold"/>
+            </a:endParaRPr>
+          </a:p>
+        </p:txBody>
+      </p:sp>
+      <p:sp>
+        <p:nvSpPr>
+          <p:cNvPr id="213" name="Design step 213"/>
+          <p:cNvSpPr txBox="1"/>
+          <p:nvPr/>
+        </p:nvSpPr>
+        <p:spPr>
+          <a:xfrm>
+            <a:off x="5952744" y="4111264"/>
+            <a:ext cx="2743200" cy="323576"/>
+          </a:xfrm>
+          <a:prstGeom prst="rect">
+            <a:avLst/>
+          </a:prstGeom>
+          <a:noFill/>
+          <a:ln>
+            <a:noFill/>
+          </a:ln>
+        </p:spPr>
+        <p:txBody>
+          <a:bodyPr wrap="square" lIns="0" tIns="0" rIns="0" bIns="0" anchor="t" rtlCol="0">
+            <a:noAutofit/>
+          </a:bodyPr>
+          <a:lstStyle/>
+          <a:p>
+            <a:pPr marL="0" indent="0" algn="l" rtl="0">
+              <a:lnSpc>
+                <a:spcPct val="96000"/>
+              </a:lnSpc>
+              <a:spcBef>
+                <a:spcPts val="0"/>
+              </a:spcBef>
+              <a:spcAft>
+                <a:spcPts val="0"/>
+              </a:spcAft>
+              <a:buNone/>
+            </a:pPr>
+            <a:r>
+              <a:rPr lang="en-GB" sz="1000" b="0" i="0" dirty="0">
+                <a:solidFill>
+                  <a:srgbClr val="46464B"/>
+                </a:solidFill>
+                <a:latin typeface="Google Sans Flex"/>
+                <a:ea typeface="Google Sans Flex"/>
+                <a:cs typeface="Google Sans Flex"/>
+                <a:sym typeface="Google Sans Flex"/>
+              </a:rPr>
+              <a:t xml:space="preserve">Click </a:t>
+            </a:r>
+            <a:r>
+              <a:rPr lang="en-GB" sz="1000" b="0" i="0" dirty="0">
+                <a:solidFill>
+                  <a:srgbClr val="111113"/>
+                </a:solidFill>
+                <a:latin typeface="Google Sans Flex SemiBold"/>
+                <a:ea typeface="Google Sans Flex SemiBold"/>
+                <a:cs typeface="Google Sans Flex SemiBold"/>
+                <a:sym typeface="Google Sans Flex SemiBold"/>
+              </a:rPr>
+              <a:t xml:space="preserve">House</a:t>
+            </a:r>
+            <a:r>
+              <a:rPr lang="en-GB" sz="1000" b="0" i="0" dirty="0">
+                <a:solidFill>
+                  <a:srgbClr val="46464B"/>
+                </a:solidFill>
+                <a:latin typeface="Google Sans Flex"/>
+                <a:ea typeface="Google Sans Flex"/>
+                <a:cs typeface="Google Sans Flex"/>
+                <a:sym typeface="Google Sans Flex"/>
+              </a:rPr>
+              <a:t xml:space="preserve"> to walk it. Ask for a change in </a:t>
+            </a:r>
+            <a:r>
+              <a:rPr lang="en-GB" sz="1000" b="0" i="0" dirty="0">
+                <a:solidFill>
+                  <a:srgbClr val="111113"/>
+                </a:solidFill>
+                <a:latin typeface="Google Sans Flex SemiBold"/>
+                <a:ea typeface="Google Sans Flex SemiBold"/>
+                <a:cs typeface="Google Sans Flex SemiBold"/>
+                <a:sym typeface="Google Sans Flex SemiBold"/>
+              </a:rPr>
+              <a:t xml:space="preserve">Tell Naqsha what to change…</a:t>
+            </a:r>
+            <a:r>
+              <a:rPr lang="en-GB" sz="1000" b="0" i="0" dirty="0">
+                <a:solidFill>
+                  <a:srgbClr val="46464B"/>
+                </a:solidFill>
+                <a:latin typeface="Google Sans Flex"/>
+                <a:ea typeface="Google Sans Flex"/>
+                <a:cs typeface="Google Sans Flex"/>
+                <a:sym typeface="Google Sans Flex"/>
+              </a:rPr>
+              <a:t xml:space="preserve"> (1–5 min).</a:t>
+            </a:r>
+            <a:endParaRPr lang="en-GB" sz="1000" dirty="0">
+              <a:latin typeface="Google Sans Flex"/>
+              <a:ea typeface="Google Sans Flex"/>
+              <a:cs typeface="Google Sans Flex"/>
+              <a:sym typeface="Google Sans Flex"/>
+            </a:endParaRPr>
+          </a:p>
+        </p:txBody>
+      </p:sp>
+      <p:sp>
+        <p:nvSpPr>
+          <p:cNvPr id="214" name="GitHub icon circle 214"/>
+          <p:cNvSpPr/>
+          <p:nvPr/>
+        </p:nvSpPr>
+        <p:spPr>
+          <a:xfrm>
+            <a:off x="356616" y="4617720"/>
+            <a:ext cx="228600" cy="228600"/>
+          </a:xfrm>
+          <a:prstGeom prst="ellipse">
+            <a:avLst/>
+          </a:prstGeom>
+          <a:solidFill>
+            <a:srgbClr val="111113"/>
+          </a:solidFill>
+          <a:ln>
+            <a:noFill/>
+          </a:ln>
+        </p:spPr>
+      </p:sp>
+      <p:pic>
+        <p:nvPicPr>
+          <p:cNvPr id="215" name="GitHub icon 215" descr=""/>
+          <p:cNvPicPr>
+            <a:picLocks noChangeAspect="1"/>
+          </p:cNvPicPr>
+          <p:nvPr/>
+        </p:nvPicPr>
+        <p:blipFill>
+          <a:blip r:embed="rId18"/>
+          <a:stretch>
+            <a:fillRect/>
+          </a:stretch>
+        </p:blipFill>
+        <p:spPr>
+          <a:xfrm>
+            <a:off x="406908" y="4668012"/>
+            <a:ext cx="128016" cy="128016"/>
+          </a:xfrm>
+          <a:prstGeom prst="rect">
+            <a:avLst/>
+          </a:prstGeom>
+          <a:noFill/>
+          <a:ln>
+            <a:noFill/>
+          </a:ln>
+        </p:spPr>
+      </p:pic>
+      <p:sp>
+        <p:nvSpPr>
+          <p:cNvPr id="216" name="Guide link 216"/>
+          <p:cNvSpPr txBox="1"/>
+          <p:nvPr/>
+        </p:nvSpPr>
+        <p:spPr>
+          <a:xfrm>
+            <a:off x="658368" y="4617720"/>
+            <a:ext cx="8129016" cy="228600"/>
+          </a:xfrm>
+          <a:prstGeom prst="rect">
+            <a:avLst/>
+          </a:prstGeom>
+          <a:noFill/>
+          <a:ln>
+            <a:noFill/>
+          </a:ln>
+        </p:spPr>
+        <p:txBody>
+          <a:bodyPr wrap="square" lIns="0" tIns="0" rIns="0" bIns="0" anchor="ctr" rtlCol="0">
+            <a:noAutofit/>
+          </a:bodyPr>
+          <a:lstStyle/>
+          <a:p>
+            <a:pPr marL="0" indent="0" algn="l" rtl="0">
+              <a:lnSpc>
+                <a:spcPct val="100000"/>
+              </a:lnSpc>
+              <a:spcBef>
+                <a:spcPts val="0"/>
+              </a:spcBef>
+              <a:spcAft>
+                <a:spcPts val="0"/>
+              </a:spcAft>
+              <a:buNone/>
+            </a:pPr>
+            <a:r>
+              <a:rPr lang="en-GB" sz="1100" b="0" i="0" dirty="0">
+                <a:solidFill>
+                  <a:srgbClr val="111113"/>
+                </a:solidFill>
+                <a:latin typeface="Google Sans Flex SemiBold"/>
+                <a:ea typeface="Google Sans Flex SemiBold"/>
+                <a:cs typeface="Google Sans Flex SemiBold"/>
+                <a:sym typeface="Google Sans Flex SemiBold"/>
+              </a:rPr>
+              <a:t xml:space="preserve">Step-by-step guide with screenshots: </a:t>
+            </a:r>
+            <a:r>
+              <a:rPr lang="en-GB" sz="1100" b="0" i="0" dirty="0">
+                <a:solidFill>
+                  <a:srgbClr val="2747F5"/>
+                </a:solidFill>
+                <a:latin typeface="Google Sans Flex Medium"/>
+                <a:ea typeface="Google Sans Flex Medium"/>
+                <a:cs typeface="Google Sans Flex Medium"/>
+                <a:sym typeface="Google Sans Flex Medium"/>
+                <a:hlinkClick r:id="rId19"/>
+              </a:rPr>
+              <a:t xml:space="preserve">github.com/abdm693/hack2skill-hackathon/blob/main/JUDGES.md</a:t>
+            </a:r>
+            <a:endParaRPr lang="en-GB" sz="1100" dirty="0">
+              <a:latin typeface="Google Sans Flex SemiBold"/>
+              <a:ea typeface="Google Sans Flex SemiBold"/>
+              <a:cs typeface="Google Sans Flex SemiBold"/>
+              <a:sym typeface="Google Sans Flex SemiBold"/>
+            </a:endParaRPr>
+          </a:p>
+        </p:txBody>
+      </p:sp>
+    </p:spTree>
+  </p:cSld>
+  <p:clrMapOvr>
+    <a:masterClrMapping/>
+  </p:clrMapOvr>
+</p:sld>
+</file>
+
 <file path=ppt/slides/slide3.xml><?xml version="1.0" encoding="utf-8"?>
 <p:sld xmlns:a="http://schemas.openxmlformats.org/drawingml/2006/main" xmlns:r="http://schemas.openxmlformats.org/officeDocument/2006/relationships" xmlns:mc="http://schemas.openxmlformats.org/markup-compatibility/2006" xmlns:mv="urn:schemas-microsoft-com:mac:vml" xmlns:p="http://schemas.openxmlformats.org/presentationml/2006/main" xmlns:c="http://schemas.openxmlformats.org/drawingml/2006/chart" xmlns:dgm="http://schemas.openxmlformats.org/drawingml/2006/diagram" xmlns:o="urn:schemas-microsoft-com:office:office" xmlns:v="urn:schemas-microsoft-com:vml" xmlns:pvml="urn:schemas-microsoft-com:office:powerpoint" xmlns:com="http://schemas.openxmlformats.org/drawingml/2006/compatibility" xmlns:p14="http://schemas.microsoft.com/office/powerpoint/2010/main" xmlns:p15="http://schemas.microsoft.com/office/powerpoint/2012/main" xmlns:ahyp="http://schemas.microsoft.com/office/drawing/2018/hyperlinkcolor">
   <p:cSld>

</xml_diff>